<commit_message>
Docs: update the slide presentation for the merged code
- Replace the EnTT/FlatGeometry slides with "The stage is the scene graph"
  and "From prim to RenderMesh" (meshoptimizer welding).
- Renderer: OptiX-IR module, one GAS per mesh plus an IAS, MeshData in
  LaunchParams.
- Drop the cloudxr-branch wording; add a slide on connecting an Apple
  Vision Pro through stunnel.
- Update counts (16 files, 4,600 lines, 149 book pages) and the build card.
- logbook: add the results entry.

Co-Authored-By: Claude Opus 5.5 <noreply@anthropic.com>
</commit_message>
<xml_diff>
--- a/Docs/UsdOptixViewer-code.pptx
+++ b/Docs/UsdOptixViewer-code.pptx
@@ -29,9 +29,10 @@
     <p:sldId id="277" r:id="rId23"/>
     <p:sldId id="278" r:id="rId24"/>
     <p:sldId id="279" r:id="rId25"/>
+    <p:sldId id="280" r:id="rId26"/>
   </p:sldIdLst>
   <p:notesMasterIdLst>
-    <p:notesMasterId r:id="rId26"/>
+    <p:notesMasterId r:id="rId27"/>
   </p:notesMasterIdLst>
   <p:sldSz cx="9144000" cy="5143500"/>
   <p:notesSz cx="5143500" cy="9144000"/>
@@ -130,7 +131,7 @@
   <p:extLst>
     <p:ext uri="{521415D9-36F7-43E2-AB2F-B90AF26B5E84}">
       <p14:sectionLst xmlns:p14="http://schemas.microsoft.com/office/powerpoint/2010/main">
-        <p14:section name="Overview" id="{4580fa43-e643-dbe9-3571-8b6ef47e3d69}">
+        <p14:section name="Overview" id="{e7d0cca7-2341-d7ae-4549-2ba9dab36367}">
           <p14:sldIdLst>
             <p14:sldId id="256"/>
             <p14:sldId id="257"/>
@@ -138,7 +139,7 @@
             <p14:sldId id="259"/>
           </p14:sldIdLst>
         </p14:section>
-        <p14:section name="Scene" id="{ff2809ff-fb50-92c8-e77e-f2778d4421cd}">
+        <p14:section name="Scene" id="{27f96ab2-730f-19d7-369e-7deccd4b008c}">
           <p14:sldIdLst>
             <p14:sldId id="260"/>
             <p14:sldId id="261"/>
@@ -147,7 +148,7 @@
             <p14:sldId id="264"/>
           </p14:sldIdLst>
         </p14:section>
-        <p14:section name="OptiX" id="{4405fe8e-d445-a772-31b3-0194d183ea97}">
+        <p14:section name="OptiX" id="{5c9d20cc-7554-7077-294b-b8cbdd6438aa}">
           <p14:sldIdLst>
             <p14:sldId id="265"/>
             <p14:sldId id="266"/>
@@ -156,7 +157,7 @@
             <p14:sldId id="269"/>
           </p14:sldIdLst>
         </p14:section>
-        <p14:section name="Application" id="{ca0056a2-8e45-df72-432f-a7aa40a3ca6d}">
+        <p14:section name="Application" id="{475fd258-60fc-ca6b-1b6c-42bb2f3ec1b2}">
           <p14:sldIdLst>
             <p14:sldId id="270"/>
             <p14:sldId id="271"/>
@@ -164,18 +165,19 @@
             <p14:sldId id="273"/>
           </p14:sldIdLst>
         </p14:section>
-        <p14:section name="XR" id="{f028a9fc-9cac-a8bf-2067-257f40596a5f}">
+        <p14:section name="XR" id="{c4e961f0-766a-8429-0875-4bad7a2d2c8a}">
           <p14:sldIdLst>
             <p14:sldId id="274"/>
             <p14:sldId id="275"/>
             <p14:sldId id="276"/>
             <p14:sldId id="277"/>
+            <p14:sldId id="278"/>
           </p14:sldIdLst>
         </p14:section>
-        <p14:section name="Wrap-up" id="{d57a012e-6bb5-fc6a-8a8b-4cc2f3229e81}">
+        <p14:section name="Wrap-up" id="{34c66b58-432f-fe67-277c-df1fa3c05f45}">
           <p14:sldIdLst>
-            <p14:sldId id="278"/>
             <p14:sldId id="279"/>
+            <p14:sldId id="280"/>
           </p14:sldIdLst>
         </p14:section>
       </p14:sectionLst>
@@ -938,7 +940,7 @@
           <a:p>
             <a:r>
               <a:rPr lang="en-US" dirty="0"/>
-              <a:t>A walkthrough of the UsdOptixViewer source code, in the order the data flows: loading the USD stage, ray tracing it with OptiX, the desktop application, and the XR output of the cloudxr branch.</a:t>
+              <a:t>A walkthrough of the UsdOptixViewer source code, in the order the data flows: loading the USD stage, ray tracing it with OptiX, the desktop application, and the XR output through CloudXR.</a:t>
             </a:r>
             <a:endParaRPr lang="en-US" dirty="0"/>
           </a:p>
@@ -1114,7 +1116,7 @@
           <a:p>
             <a:r>
               <a:rPr lang="en-US" dirty="0"/>
-              <a:t>init runs once (or again on another GPU in the cloudxr branch, through release()). The PTX is compiled by nvcc at build time and embedded with cmake/EmbedFile.cmake, so the binary is self-contained.</a:t>
+              <a:t>init runs once (or again on the XR runtime's GPU, through release()). nvcc compiles the device programs to OptiX-IR (-optix-ir) at build time; cmake/EmbedFile.cmake embeds the binary as an unsigned char array, so the executable is self-contained.</a:t>
             </a:r>
             <a:endParaRPr lang="en-US" dirty="0"/>
           </a:p>
@@ -1290,7 +1292,7 @@
           <a:p>
             <a:r>
               <a:rPr lang="en-US" dirty="0"/>
-              <a:t>sampleTexture picks the mip level from ray differentials: rays through neighbouring pixels are intersected with the triangle's plane and turned into st gradients for tex2DGrad.</a:t>
+              <a:t>HitTriangle reads the hit mesh by optixGetInstanceId() and takes its vertices and normals to world space with the instance transform. sampleTexture picks the mip level from ray differentials: rays through neighbouring pixels are intersected with the triangle's plane and turned into st gradients for tex2DGrad.</a:t>
             </a:r>
             <a:endParaRPr lang="en-US" dirty="0"/>
           </a:p>
@@ -1906,7 +1908,7 @@
           <a:p>
             <a:r>
               <a:rPr lang="en-US" dirty="0"/>
-              <a:t>Counts are for the cloudxr branch. main has 13 files: it lacks XrOutput and CloudXrService. The literate book in LiterateP/ contains every line of the code with prose.</a:t>
+              <a:t>Counts exclude the third-party stb_image.h and cxrServiceAPI.h. The literate book in LiterateP/ contains every line of the 16 files with prose. Every library is installed for all users in /opt/viztools.</a:t>
             </a:r>
             <a:endParaRPr lang="en-US" dirty="0"/>
           </a:p>
@@ -2170,7 +2172,7 @@
           <a:p>
             <a:r>
               <a:rPr lang="en-US" dirty="0"/>
-              <a:t>--cloudxr starts the CloudXR service in-process (CloudXrService dlopens libcloudxr.so and restores SDL's signal handlers); --xr uses a runtime already running, e.g. from Isaac Teleop. CLOUDXR.md lists every difference from main.</a:t>
+              <a:t>--cloudxr starts the CloudXR service in-process (CloudXrService dlopens libcloudxr.so and restores SDL's signal handlers); --xr uses a runtime already running, e.g. from Isaac Teleop. The SDK comes from --cloudxr-sdk, $CLOUDXR_SDK_DIR or /opt/viztools/cloudxr-6.2.1.</a:t>
             </a:r>
             <a:endParaRPr lang="en-US" dirty="0"/>
           </a:p>
@@ -2258,7 +2260,7 @@
           <a:p>
             <a:r>
               <a:rPr lang="en-US" dirty="0"/>
-              <a:t>CLAUDE.md has the exact build, test and book commands. Every code change must also update the matching chunk in LiterateP/src and pass lp.py check.</a:t>
+              <a:t>Tested on October 27th: two sessions of 3 and 4 minutes with the color, alpha/depth, input and audio streams connected. The client only speaks TLS to 48322, so stunnel forwards to the runtime. The menu shows the runtime's port (48324), not stunnel's. Details in CLOUDXR.md.</a:t>
             </a:r>
             <a:endParaRPr lang="en-US" dirty="0"/>
           </a:p>
@@ -2346,7 +2348,7 @@
           <a:p>
             <a:r>
               <a:rPr lang="en-US" dirty="0"/>
-              <a:t>The shared header shows what the GPU needs; Scene.cpp shows how USD becomes that; the device programs show how it becomes light; App.cpp ties it together.</a:t>
+              <a:t>CLAUDE.md has the exact build, test and book commands. Every code change must also update the matching chunk in LiterateP/src and pass lp.py check.</a:t>
             </a:r>
             <a:endParaRPr lang="en-US" dirty="0"/>
           </a:p>
@@ -2370,6 +2372,94 @@
             <a:fld id="{F7021451-1387-4CA6-816F-3879F97B5CBC}" type="slidenum">
               <a:rPr lang="en-US"/>
               <a:t>24</a:t>
+            </a:fld>
+            <a:endParaRPr lang="en-US"/>
+          </a:p>
+        </p:txBody>
+      </p:sp>
+    </p:spTree>
+    <p:extLst>
+      <p:ext uri="{BB962C8B-B14F-4D97-AF65-F5344CB8AC3E}">
+        <p14:creationId xmlns:p14="http://schemas.microsoft.com/office/powerpoint/2010/main" val="1024086991"/>
+      </p:ext>
+    </p:extLst>
+  </p:cSld>
+  <p:clrMapOvr>
+    <a:masterClrMapping/>
+  </p:clrMapOvr>
+</p:notes>
+</file>
+
+<file path=ppt/notesSlides/notesSlide25.xml><?xml version="1.0" encoding="utf-8"?>
+<p:notes xmlns:a="http://schemas.openxmlformats.org/drawingml/2006/main" xmlns:r="http://schemas.openxmlformats.org/officeDocument/2006/relationships" xmlns:p="http://schemas.openxmlformats.org/presentationml/2006/main">
+  <p:cSld>
+    <p:spTree>
+      <p:nvGrpSpPr>
+        <p:cNvPr id="1" name=""/>
+        <p:cNvGrpSpPr/>
+        <p:nvPr/>
+      </p:nvGrpSpPr>
+      <p:grpSpPr>
+        <a:xfrm>
+          <a:off x="0" y="0"/>
+          <a:ext cx="0" cy="0"/>
+          <a:chOff x="0" y="0"/>
+          <a:chExt cx="0" cy="0"/>
+        </a:xfrm>
+      </p:grpSpPr>
+      <p:sp>
+        <p:nvSpPr>
+          <p:cNvPr id="2" name="Slide Image Placeholder 1"/>
+          <p:cNvSpPr>
+            <a:spLocks noGrp="1" noRot="1" noChangeAspect="1"/>
+          </p:cNvSpPr>
+          <p:nvPr>
+            <p:ph type="sldImg"/>
+          </p:nvPr>
+        </p:nvSpPr>
+        <p:spPr/>
+      </p:sp>
+      <p:sp>
+        <p:nvSpPr>
+          <p:cNvPr id="3" name="Notes Placeholder 2"/>
+          <p:cNvSpPr>
+            <a:spLocks noGrp="1"/>
+          </p:cNvSpPr>
+          <p:nvPr>
+            <p:ph type="body" idx="1"/>
+          </p:nvPr>
+        </p:nvSpPr>
+        <p:spPr/>
+        <p:txBody>
+          <a:bodyPr/>
+          <a:lstStyle/>
+          <a:p>
+            <a:r>
+              <a:rPr lang="en-US" dirty="0"/>
+              <a:t>The shared header shows what the GPU needs; Scene.cpp shows how USD becomes that; the device programs show how it becomes light; App.cpp ties it together.</a:t>
+            </a:r>
+            <a:endParaRPr lang="en-US" dirty="0"/>
+          </a:p>
+        </p:txBody>
+      </p:sp>
+      <p:sp>
+        <p:nvSpPr>
+          <p:cNvPr id="4" name="Slide Number Placeholder 3"/>
+          <p:cNvSpPr>
+            <a:spLocks noGrp="1"/>
+          </p:cNvSpPr>
+          <p:nvPr>
+            <p:ph type="sldNum" sz="quarter" idx="10"/>
+          </p:nvPr>
+        </p:nvSpPr>
+        <p:spPr/>
+        <p:txBody>
+          <a:bodyPr/>
+          <a:lstStyle/>
+          <a:p>
+            <a:fld id="{F7021451-1387-4CA6-816F-3879F97B5CBC}" type="slidenum">
+              <a:rPr lang="en-US"/>
+              <a:t>25</a:t>
             </a:fld>
             <a:endParaRPr lang="en-US"/>
           </a:p>
@@ -2522,7 +2612,7 @@
           <a:p>
             <a:r>
               <a:rPr lang="en-US" dirty="0"/>
-              <a:t>Scene.* converts USD into an EnTT registry and flat world-space triangle arrays. OptixRenderer.* uploads them and launches the OptiX programs in devicePrograms.cu. App.* owns the window, the panels and the camera. XrOutput (cloudxr branch) sends eye images to an OpenXR runtime.</a:t>
+              <a:t>The USD stage is the scene graph. Scene.* turns each renderable prim into a RenderMesh (local-space indexed mesh + transform) and resolves materials and cameras. OptixRenderer.* uploads them and launches the OptiX programs in devicePrograms.cu. App.* owns the window, the panels and the camera. XrOutput sends eye images to an OpenXR runtime.</a:t>
             </a:r>
             <a:endParaRPr lang="en-US" dirty="0"/>
           </a:p>
@@ -2698,7 +2788,7 @@
           <a:p>
             <a:r>
               <a:rPr lang="en-US" dirty="0"/>
-              <a:t>createEntities walks the stage with UsdTraverseInstanceProxies and creates one entity per prim. Components are added by later passes: extractGeometry adds MeshGeometry, extractCameras adds CameraView.</a:t>
+              <a:t>load() opens the stage, then extractGeometry and extractCameras walk it with UsdTraverseInstanceProxies. Only renderable prims become RenderMesh records, so "is it drawn?" is meshIndex(path) &gt;= 0.</a:t>
             </a:r>
             <a:endParaRPr lang="en-US" dirty="0"/>
           </a:p>
@@ -2786,7 +2876,7 @@
           <a:p>
             <a:r>
               <a:rPr lang="en-US" dirty="0"/>
-              <a:t>Everything the GPU needs per hit is indexed by the triangle index OptiX reports, so all the attribute arrays are per triangle. A zero shading normal means flat shading.</a:t>
+              <a:t>weldCorners: meshopt_generateVertexRemapMulti merges corners with identical position, normal and st; triangles are grouped by material and spatially sorted (meshopt_spatialSortTriangles); meshopt_optimizeVertexFetchRemap stores vertices in first-use order. The mesh stays in local space.</a:t>
             </a:r>
             <a:endParaRPr lang="en-US" dirty="0"/>
           </a:p>
@@ -4651,7 +4741,7 @@
                   <a:schemeClr val="tx1"/>
                 </a:solidFill>
               </a:rPr>
-              <a:t>Module from embedded PTX</a:t>
+              <a:t>Module from embedded OptiX-IR</a:t>
             </a:r>
             <a:endParaRPr lang="en-US" sz="1500" dirty="0"/>
           </a:p>
@@ -4908,7 +4998,7 @@
                   <a:schemeClr val="tx1"/>
                 </a:solidFill>
               </a:rPr>
-              <a:t>setGeometry(FlatGeometry)</a:t>
+              <a:t>setScene(Scene)</a:t>
             </a:r>
             <a:endParaRPr lang="en-US" sz="1600" dirty="0"/>
           </a:p>
@@ -4948,7 +5038,7 @@
                   <a:schemeClr val="tx1"/>
                 </a:solidFill>
               </a:rPr>
-              <a:t>Uploads the arrays and textures</a:t>
+              <a:t>One compacted GAS per mesh (local space)</a:t>
             </a:r>
             <a:endParaRPr lang="en-US" sz="1400" dirty="0"/>
           </a:p>
@@ -4966,7 +5056,7 @@
                   <a:schemeClr val="tx1"/>
                 </a:solidFill>
               </a:rPr>
-              <a:t>Builds one compacted GAS over all triangles</a:t>
+              <a:t>An IAS places them: instance id = mesh id</a:t>
             </a:r>
             <a:endParaRPr lang="en-US" sz="1400" dirty="0"/>
           </a:p>
@@ -5449,7 +5539,7 @@
                 <a:ea typeface="Courier New" pitchFamily="34" charset="-122"/>
                 <a:cs typeface="Courier New" pitchFamily="34" charset="-120"/>
               </a:rPr>
-              <a:t>    const float3* vertices; ...</a:t>
+              <a:t>    const MeshData* meshes;// per instance</a:t>
             </a:r>
             <a:endParaRPr lang="en-US" sz="1200" dirty="0"/>
           </a:p>
@@ -7294,7 +7384,7 @@
                   <a:schemeClr val="tx1"/>
                 </a:solidFill>
               </a:rPr>
-              <a:t>headset frame (cloudxr branch)</a:t>
+              <a:t>headset frame, when a session runs</a:t>
             </a:r>
             <a:endParaRPr lang="en-US" sz="1400" dirty="0"/>
           </a:p>
@@ -8920,7 +9010,7 @@
                   <a:schemeClr val="bg2"/>
                 </a:solidFill>
               </a:rPr>
-              <a:t>cloudxr branch: XrOutput.* and CloudXrService.*</a:t>
+              <a:t>XrOutput.* and CloudXrService.*: OpenXR through CloudXR</a:t>
             </a:r>
             <a:endParaRPr lang="en-US" sz="1600" dirty="0"/>
           </a:p>
@@ -9067,7 +9157,7 @@
                 <a:ea typeface="Cambria" pitchFamily="34" charset="-122"/>
                 <a:cs typeface="Cambria" pitchFamily="34" charset="-120"/>
               </a:rPr>
-              <a:t>17</a:t>
+              <a:t>16</a:t>
             </a:r>
             <a:endParaRPr lang="en-US" sz="4800" dirty="0"/>
           </a:p>
@@ -9156,7 +9246,7 @@
                 <a:ea typeface="Cambria" pitchFamily="34" charset="-122"/>
                 <a:cs typeface="Cambria" pitchFamily="34" charset="-120"/>
               </a:rPr>
-              <a:t>4,400</a:t>
+              <a:t>4,600</a:t>
             </a:r>
             <a:endParaRPr lang="en-US" sz="4800" dirty="0"/>
           </a:p>
@@ -9295,7 +9385,7 @@
                   <a:schemeClr val="accent4"/>
                 </a:solidFill>
               </a:rPr>
-              <a:t>OpenUSD, EnTT, OptiX, SDL3 + ImGui, OpenXR</a:t>
+              <a:t>OpenUSD, meshoptimizer, OptiX, SDL3 + ImGui, OpenXR</a:t>
             </a:r>
             <a:endParaRPr lang="en-US" sz="1600" dirty="0"/>
           </a:p>
@@ -9334,7 +9424,7 @@
                 <a:ea typeface="Cambria" pitchFamily="34" charset="-122"/>
                 <a:cs typeface="Cambria" pitchFamily="34" charset="-120"/>
               </a:rPr>
-              <a:t>143</a:t>
+              <a:t>149</a:t>
             </a:r>
             <a:endParaRPr lang="en-US" sz="4800" dirty="0"/>
           </a:p>
@@ -9523,7 +9613,7 @@
                   <a:schemeClr val="tx1"/>
                 </a:solidFill>
               </a:rPr>
-              <a:t>Looks through USD cameras; on the cloudxr branch, streams stereo to a headset through CloudXR</a:t>
+              <a:t>Looks through USD cameras and streams stereo to a headset (Vision Pro tested) through CloudXR</a:t>
             </a:r>
             <a:endParaRPr lang="en-US" sz="1400" dirty="0"/>
           </a:p>
@@ -10226,7 +10316,7 @@
                 <a:ea typeface="Cambria" pitchFamily="34" charset="-122"/>
                 <a:cs typeface="Cambria" pitchFamily="34" charset="-120"/>
               </a:rPr>
-              <a:t>2.8 ms</a:t>
+              <a:t>2.6 ms</a:t>
             </a:r>
             <a:endParaRPr lang="en-US" sz="3000" dirty="0"/>
           </a:p>
@@ -11567,7 +11657,7 @@
                   <a:schemeClr val="tx1"/>
                 </a:solidFill>
               </a:rPr>
-              <a:t>Build, test and document</a:t>
+              <a:t>Connecting an Apple Vision Pro</a:t>
             </a:r>
             <a:endParaRPr lang="en-US" sz="3000" dirty="0"/>
           </a:p>
@@ -11575,18 +11665,18 @@
       </p:sp>
       <p:sp>
         <p:nvSpPr>
-          <p:cNvPr id="3" name="card-239"/>
+          <p:cNvPr id="3" name="box-239"/>
           <p:cNvSpPr/>
           <p:nvPr/>
         </p:nvSpPr>
         <p:spPr>
           <a:xfrm>
-            <a:off x="457200" y="1188720"/>
-            <a:ext cx="2606040" cy="2011680"/>
+            <a:off x="457200" y="1234440"/>
+            <a:ext cx="1600200" cy="914400"/>
           </a:xfrm>
           <a:prstGeom prst="roundRect">
             <a:avLst>
-              <a:gd name="adj" fmla="val 3636"/>
+              <a:gd name="adj" fmla="val 8000"/>
             </a:avLst>
           </a:prstGeom>
           <a:solidFill>
@@ -11602,17 +11692,223 @@
       </p:sp>
       <p:sp>
         <p:nvSpPr>
-          <p:cNvPr id="4" name="badge-240"/>
+          <p:cNvPr id="4" name="box-text-240"/>
+          <p:cNvSpPr txBox="1"/>
+          <p:nvPr/>
+        </p:nvSpPr>
+        <p:spPr>
+          <a:xfrm>
+            <a:off x="530352" y="1234440"/>
+            <a:ext cx="1453896" cy="914400"/>
+          </a:xfrm>
+          <a:prstGeom prst="rect">
+            <a:avLst/>
+          </a:prstGeom>
+          <a:noFill/>
+          <a:ln/>
+        </p:spPr>
+        <p:txBody>
+          <a:bodyPr wrap="square" lIns="0" tIns="0" rIns="0" bIns="0" rtlCol="0" anchor="ctr"/>
+          <a:lstStyle/>
+          <a:p>
+            <a:pPr algn="ctr" indent="0" marL="0">
+              <a:buNone/>
+            </a:pPr>
+            <a:r>
+              <a:rPr lang="en-US" sz="1400" b="1" dirty="0">
+                <a:solidFill>
+                  <a:schemeClr val="tx1"/>
+                </a:solidFill>
+              </a:rPr>
+              <a:t>Vision Pro</a:t>
+            </a:r>
+            <a:endParaRPr lang="en-US" sz="1400" dirty="0"/>
+          </a:p>
+          <a:p>
+            <a:pPr algn="ctr" indent="0" marL="0">
+              <a:buNone/>
+            </a:pPr>
+            <a:r>
+              <a:rPr lang="en-US" sz="1100" dirty="0">
+                <a:solidFill>
+                  <a:schemeClr val="tx1"/>
+                </a:solidFill>
+              </a:rPr>
+              <a:t>CloudXRViewer</a:t>
+            </a:r>
+            <a:endParaRPr lang="en-US" sz="1400" dirty="0"/>
+          </a:p>
+        </p:txBody>
+      </p:sp>
+      <p:sp>
+        <p:nvSpPr>
+          <p:cNvPr id="5" name="box-241"/>
           <p:cNvSpPr/>
           <p:nvPr/>
         </p:nvSpPr>
         <p:spPr>
           <a:xfrm>
-            <a:off x="594360" y="1325880"/>
-            <a:ext cx="384048" cy="384048"/>
-          </a:xfrm>
-          <a:prstGeom prst="ellipse">
-            <a:avLst/>
+            <a:off x="2514600" y="1234440"/>
+            <a:ext cx="1600200" cy="914400"/>
+          </a:xfrm>
+          <a:prstGeom prst="roundRect">
+            <a:avLst>
+              <a:gd name="adj" fmla="val 8000"/>
+            </a:avLst>
+          </a:prstGeom>
+          <a:solidFill>
+            <a:srgbClr val="E8A33D"/>
+          </a:solidFill>
+          <a:ln w="12700">
+            <a:solidFill>
+              <a:srgbClr val="E8A33D"/>
+            </a:solidFill>
+            <a:prstDash val="solid"/>
+          </a:ln>
+        </p:spPr>
+      </p:sp>
+      <p:sp>
+        <p:nvSpPr>
+          <p:cNvPr id="6" name="box-text-242"/>
+          <p:cNvSpPr txBox="1"/>
+          <p:nvPr/>
+        </p:nvSpPr>
+        <p:spPr>
+          <a:xfrm>
+            <a:off x="2587752" y="1234440"/>
+            <a:ext cx="1453896" cy="914400"/>
+          </a:xfrm>
+          <a:prstGeom prst="rect">
+            <a:avLst/>
+          </a:prstGeom>
+          <a:noFill/>
+          <a:ln/>
+        </p:spPr>
+        <p:txBody>
+          <a:bodyPr wrap="square" lIns="0" tIns="0" rIns="0" bIns="0" rtlCol="0" anchor="ctr"/>
+          <a:lstStyle/>
+          <a:p>
+            <a:pPr algn="ctr" indent="0" marL="0">
+              <a:buNone/>
+            </a:pPr>
+            <a:r>
+              <a:rPr lang="en-US" sz="1400" b="1" dirty="0">
+                <a:solidFill>
+                  <a:schemeClr val="tx1"/>
+                </a:solidFill>
+              </a:rPr>
+              <a:t>stunnel</a:t>
+            </a:r>
+            <a:endParaRPr lang="en-US" sz="1400" dirty="0"/>
+          </a:p>
+          <a:p>
+            <a:pPr algn="ctr" indent="0" marL="0">
+              <a:buNone/>
+            </a:pPr>
+            <a:r>
+              <a:rPr lang="en-US" sz="1100" dirty="0">
+                <a:solidFill>
+                  <a:schemeClr val="tx1"/>
+                </a:solidFill>
+              </a:rPr>
+              <a:t>TLS on :48322</a:t>
+            </a:r>
+            <a:endParaRPr lang="en-US" sz="1400" dirty="0"/>
+          </a:p>
+        </p:txBody>
+      </p:sp>
+      <p:sp>
+        <p:nvSpPr>
+          <p:cNvPr id="7" name="box-243"/>
+          <p:cNvSpPr/>
+          <p:nvPr/>
+        </p:nvSpPr>
+        <p:spPr>
+          <a:xfrm>
+            <a:off x="4572000" y="1234440"/>
+            <a:ext cx="1828800" cy="914400"/>
+          </a:xfrm>
+          <a:prstGeom prst="roundRect">
+            <a:avLst>
+              <a:gd name="adj" fmla="val 8000"/>
+            </a:avLst>
+          </a:prstGeom>
+          <a:solidFill>
+            <a:schemeClr val="tx2"/>
+          </a:solidFill>
+          <a:ln w="12700">
+            <a:solidFill>
+              <a:schemeClr val="tx2"/>
+            </a:solidFill>
+            <a:prstDash val="solid"/>
+          </a:ln>
+        </p:spPr>
+      </p:sp>
+      <p:sp>
+        <p:nvSpPr>
+          <p:cNvPr id="8" name="box-text-244"/>
+          <p:cNvSpPr txBox="1"/>
+          <p:nvPr/>
+        </p:nvSpPr>
+        <p:spPr>
+          <a:xfrm>
+            <a:off x="4645152" y="1234440"/>
+            <a:ext cx="1682496" cy="914400"/>
+          </a:xfrm>
+          <a:prstGeom prst="rect">
+            <a:avLst/>
+          </a:prstGeom>
+          <a:noFill/>
+          <a:ln/>
+        </p:spPr>
+        <p:txBody>
+          <a:bodyPr wrap="square" lIns="0" tIns="0" rIns="0" bIns="0" rtlCol="0" anchor="ctr"/>
+          <a:lstStyle/>
+          <a:p>
+            <a:pPr algn="ctr" indent="0" marL="0">
+              <a:buNone/>
+            </a:pPr>
+            <a:r>
+              <a:rPr lang="en-US" sz="1400" b="1" dirty="0">
+                <a:solidFill>
+                  <a:schemeClr val="bg1"/>
+                </a:solidFill>
+              </a:rPr>
+              <a:t>CloudXR runtime</a:t>
+            </a:r>
+            <a:endParaRPr lang="en-US" sz="1400" dirty="0"/>
+          </a:p>
+          <a:p>
+            <a:pPr algn="ctr" indent="0" marL="0">
+              <a:buNone/>
+            </a:pPr>
+            <a:r>
+              <a:rPr lang="en-US" sz="1100" dirty="0">
+                <a:solidFill>
+                  <a:schemeClr val="bg1"/>
+                </a:solidFill>
+              </a:rPr>
+              <a:t>127.0.0.1:48324</a:t>
+            </a:r>
+            <a:endParaRPr lang="en-US" sz="1400" dirty="0"/>
+          </a:p>
+        </p:txBody>
+      </p:sp>
+      <p:sp>
+        <p:nvSpPr>
+          <p:cNvPr id="9" name="box-245"/>
+          <p:cNvSpPr/>
+          <p:nvPr/>
+        </p:nvSpPr>
+        <p:spPr>
+          <a:xfrm>
+            <a:off x="6858000" y="1234440"/>
+            <a:ext cx="1828800" cy="914400"/>
+          </a:xfrm>
+          <a:prstGeom prst="roundRect">
+            <a:avLst>
+              <a:gd name="adj" fmla="val 8000"/>
+            </a:avLst>
           </a:prstGeom>
           <a:solidFill>
             <a:schemeClr val="accent1"/>
@@ -11627,14 +11923,14 @@
       </p:sp>
       <p:sp>
         <p:nvSpPr>
-          <p:cNvPr id="5" name="badge-text-241"/>
+          <p:cNvPr id="10" name="box-text-246"/>
           <p:cNvSpPr txBox="1"/>
           <p:nvPr/>
         </p:nvSpPr>
         <p:spPr>
           <a:xfrm>
-            <a:off x="594360" y="1325880"/>
-            <a:ext cx="384048" cy="384048"/>
+            <a:off x="6931152" y="1234440"/>
+            <a:ext cx="1682496" cy="914400"/>
           </a:xfrm>
           <a:prstGeom prst="rect">
             <a:avLst/>
@@ -11655,156 +11951,112 @@
                   <a:schemeClr val="tx1"/>
                 </a:solidFill>
               </a:rPr>
-              <a:t>B</a:t>
+              <a:t>UsdOptixViewer</a:t>
             </a:r>
             <a:endParaRPr lang="en-US" sz="1400" dirty="0"/>
           </a:p>
-        </p:txBody>
-      </p:sp>
-      <p:sp>
-        <p:nvSpPr>
-          <p:cNvPr id="6" name="card-head-242"/>
-          <p:cNvSpPr txBox="1"/>
-          <p:nvPr/>
-        </p:nvSpPr>
-        <p:spPr>
-          <a:xfrm>
-            <a:off x="1078992" y="1325880"/>
-            <a:ext cx="1847088" cy="384048"/>
-          </a:xfrm>
-          <a:prstGeom prst="rect">
-            <a:avLst/>
-          </a:prstGeom>
-          <a:noFill/>
-          <a:ln/>
-        </p:spPr>
-        <p:txBody>
-          <a:bodyPr wrap="square" lIns="0" tIns="0" rIns="0" bIns="0" rtlCol="0" anchor="ctr"/>
-          <a:lstStyle/>
-          <a:p>
-            <a:pPr indent="0" marL="0">
-              <a:buNone/>
-            </a:pPr>
-            <a:r>
-              <a:rPr lang="en-US" sz="1600" b="1" dirty="0">
-                <a:solidFill>
-                  <a:schemeClr val="tx1"/>
-                </a:solidFill>
-              </a:rPr>
-              <a:t>Build</a:t>
-            </a:r>
-            <a:endParaRPr lang="en-US" sz="1600" dirty="0"/>
-          </a:p>
-        </p:txBody>
-      </p:sp>
-      <p:sp>
-        <p:nvSpPr>
-          <p:cNvPr id="7" name="card-body-243"/>
-          <p:cNvSpPr txBox="1"/>
-          <p:nvPr/>
-        </p:nvSpPr>
-        <p:spPr>
-          <a:xfrm>
-            <a:off x="640080" y="1783080"/>
-            <a:ext cx="2286000" cy="1325880"/>
-          </a:xfrm>
-          <a:prstGeom prst="rect">
-            <a:avLst/>
-          </a:prstGeom>
-          <a:noFill/>
-          <a:ln/>
-        </p:spPr>
-        <p:txBody>
-          <a:bodyPr wrap="square" lIns="0" tIns="0" rIns="0" bIns="0" rtlCol="0" anchor="t"/>
-          <a:lstStyle/>
-          <a:p>
-            <a:pPr marL="342900" indent="-342900">
-              <a:spcAft>
-                <a:spcPts val="400"/>
-              </a:spcAft>
-              <a:buSzPct val="100000"/>
-              <a:buChar char="•"/>
-            </a:pPr>
-            <a:r>
-              <a:rPr lang="en-US" sz="1400" dirty="0">
-                <a:solidFill>
-                  <a:schemeClr val="tx1"/>
-                </a:solidFill>
-              </a:rPr>
-              <a:t>CMake 3.28, C++20</a:t>
+          <a:p>
+            <a:pPr algn="ctr" indent="0" marL="0">
+              <a:buNone/>
+            </a:pPr>
+            <a:r>
+              <a:rPr lang="en-US" sz="1100" dirty="0">
+                <a:solidFill>
+                  <a:schemeClr val="tx1"/>
+                </a:solidFill>
+              </a:rPr>
+              <a:t>--cloudxr</a:t>
             </a:r>
             <a:endParaRPr lang="en-US" sz="1400" dirty="0"/>
           </a:p>
-          <a:p>
-            <a:pPr marL="342900" indent="-342900">
-              <a:spcAft>
-                <a:spcPts val="400"/>
-              </a:spcAft>
-              <a:buSzPct val="100000"/>
-              <a:buChar char="•"/>
-            </a:pPr>
-            <a:r>
-              <a:rPr lang="en-US" sz="1400" dirty="0">
-                <a:solidFill>
-                  <a:schemeClr val="tx1"/>
-                </a:solidFill>
-              </a:rPr>
-              <a:t>PTX embedded</a:t>
-            </a:r>
-            <a:endParaRPr lang="en-US" sz="1400" dirty="0"/>
-          </a:p>
-          <a:p>
-            <a:pPr marL="342900" indent="-342900">
-              <a:spcAft>
-                <a:spcPts val="400"/>
-              </a:spcAft>
-              <a:buSzPct val="100000"/>
-              <a:buChar char="•"/>
-            </a:pPr>
-            <a:r>
-              <a:rPr lang="en-US" sz="1400" dirty="0">
-                <a:solidFill>
-                  <a:schemeClr val="tx1"/>
-                </a:solidFill>
-              </a:rPr>
-              <a:t>OpenXR fetched</a:t>
-            </a:r>
-            <a:endParaRPr lang="en-US" sz="1400" dirty="0"/>
-          </a:p>
-          <a:p>
-            <a:pPr marL="342900" indent="-342900">
-              <a:spcAft>
-                <a:spcPts val="400"/>
-              </a:spcAft>
-              <a:buSzPct val="100000"/>
-              <a:buChar char="•"/>
-            </a:pPr>
-            <a:r>
-              <a:rPr lang="en-US" sz="1400" dirty="0">
-                <a:solidFill>
-                  <a:schemeClr val="tx1"/>
-                </a:solidFill>
-              </a:rPr>
-              <a:t>No warnings</a:t>
-            </a:r>
-            <a:endParaRPr lang="en-US" sz="1400" dirty="0"/>
-          </a:p>
-        </p:txBody>
-      </p:sp>
-      <p:sp>
-        <p:nvSpPr>
-          <p:cNvPr id="8" name="card-244"/>
+        </p:txBody>
+      </p:sp>
+      <p:sp>
+        <p:nvSpPr>
+          <p:cNvPr id="11" name="arrow-247"/>
           <p:cNvSpPr/>
           <p:nvPr/>
         </p:nvSpPr>
         <p:spPr>
           <a:xfrm>
-            <a:off x="3268980" y="1188720"/>
-            <a:ext cx="2606040" cy="2011680"/>
+            <a:off x="2057400" y="1691640"/>
+            <a:ext cx="457200" cy="0"/>
+          </a:xfrm>
+          <a:prstGeom prst="line">
+            <a:avLst/>
+          </a:prstGeom>
+          <a:noFill/>
+          <a:ln w="25400">
+            <a:solidFill>
+              <a:srgbClr val="8B95A1"/>
+            </a:solidFill>
+            <a:prstDash val="solid"/>
+            <a:tailEnd type="triangle"/>
+          </a:ln>
+        </p:spPr>
+      </p:sp>
+      <p:sp>
+        <p:nvSpPr>
+          <p:cNvPr id="12" name="arrow-248"/>
+          <p:cNvSpPr/>
+          <p:nvPr/>
+        </p:nvSpPr>
+        <p:spPr>
+          <a:xfrm>
+            <a:off x="4114800" y="1691640"/>
+            <a:ext cx="457200" cy="0"/>
+          </a:xfrm>
+          <a:prstGeom prst="line">
+            <a:avLst/>
+          </a:prstGeom>
+          <a:noFill/>
+          <a:ln w="25400">
+            <a:solidFill>
+              <a:srgbClr val="8B95A1"/>
+            </a:solidFill>
+            <a:prstDash val="solid"/>
+            <a:tailEnd type="triangle"/>
+          </a:ln>
+        </p:spPr>
+      </p:sp>
+      <p:sp>
+        <p:nvSpPr>
+          <p:cNvPr id="13" name="arrow-249"/>
+          <p:cNvSpPr/>
+          <p:nvPr/>
+        </p:nvSpPr>
+        <p:spPr>
+          <a:xfrm>
+            <a:off x="6400800" y="1691640"/>
+            <a:ext cx="457200" cy="0"/>
+          </a:xfrm>
+          <a:prstGeom prst="line">
+            <a:avLst/>
+          </a:prstGeom>
+          <a:noFill/>
+          <a:ln w="25400">
+            <a:solidFill>
+              <a:srgbClr val="8B95A1"/>
+            </a:solidFill>
+            <a:prstDash val="solid"/>
+            <a:tailEnd type="triangle"/>
+          </a:ln>
+        </p:spPr>
+      </p:sp>
+      <p:sp>
+        <p:nvSpPr>
+          <p:cNvPr id="14" name="card-250"/>
+          <p:cNvSpPr/>
+          <p:nvPr/>
+        </p:nvSpPr>
+        <p:spPr>
+          <a:xfrm>
+            <a:off x="457200" y="2468880"/>
+            <a:ext cx="4663440" cy="2103120"/>
           </a:xfrm>
           <a:prstGeom prst="roundRect">
             <a:avLst>
-              <a:gd name="adj" fmla="val 3636"/>
+              <a:gd name="adj" fmla="val 3478"/>
             </a:avLst>
           </a:prstGeom>
           <a:solidFill>
@@ -11820,39 +12072,14 @@
       </p:sp>
       <p:sp>
         <p:nvSpPr>
-          <p:cNvPr id="9" name="badge-245"/>
-          <p:cNvSpPr/>
-          <p:nvPr/>
-        </p:nvSpPr>
-        <p:spPr>
-          <a:xfrm>
-            <a:off x="3406140" y="1325880"/>
-            <a:ext cx="384048" cy="384048"/>
-          </a:xfrm>
-          <a:prstGeom prst="ellipse">
-            <a:avLst/>
-          </a:prstGeom>
-          <a:solidFill>
-            <a:schemeClr val="accent1"/>
-          </a:solidFill>
-          <a:ln w="12700">
-            <a:solidFill>
-              <a:schemeClr val="accent1"/>
-            </a:solidFill>
-            <a:prstDash val="solid"/>
-          </a:ln>
-        </p:spPr>
-      </p:sp>
-      <p:sp>
-        <p:nvSpPr>
-          <p:cNvPr id="10" name="badge-text-246"/>
+          <p:cNvPr id="15" name="card-head-251"/>
           <p:cNvSpPr txBox="1"/>
           <p:nvPr/>
         </p:nvSpPr>
         <p:spPr>
           <a:xfrm>
-            <a:off x="3406140" y="1325880"/>
-            <a:ext cx="384048" cy="384048"/>
+            <a:off x="640080" y="2606040"/>
+            <a:ext cx="4343400" cy="384048"/>
           </a:xfrm>
           <a:prstGeom prst="rect">
             <a:avLst/>
@@ -11864,67 +12091,31 @@
           <a:bodyPr wrap="square" lIns="0" tIns="0" rIns="0" bIns="0" rtlCol="0" anchor="ctr"/>
           <a:lstStyle/>
           <a:p>
-            <a:pPr algn="ctr" indent="0" marL="0">
-              <a:buNone/>
-            </a:pPr>
-            <a:r>
-              <a:rPr lang="en-US" sz="1400" b="1" dirty="0">
-                <a:solidFill>
-                  <a:schemeClr val="tx1"/>
-                </a:solidFill>
-              </a:rPr>
-              <a:t>T</a:t>
-            </a:r>
-            <a:endParaRPr lang="en-US" sz="1400" dirty="0"/>
-          </a:p>
-        </p:txBody>
-      </p:sp>
-      <p:sp>
-        <p:nvSpPr>
-          <p:cNvPr id="11" name="card-head-247"/>
+            <a:pPr indent="0" marL="0">
+              <a:buNone/>
+            </a:pPr>
+            <a:r>
+              <a:rPr lang="en-US" sz="1600" b="1" dirty="0">
+                <a:solidFill>
+                  <a:schemeClr val="tx1"/>
+                </a:solidFill>
+              </a:rPr>
+              <a:t>Steps</a:t>
+            </a:r>
+            <a:endParaRPr lang="en-US" sz="1600" dirty="0"/>
+          </a:p>
+        </p:txBody>
+      </p:sp>
+      <p:sp>
+        <p:nvSpPr>
+          <p:cNvPr id="16" name="card-body-252"/>
           <p:cNvSpPr txBox="1"/>
           <p:nvPr/>
         </p:nvSpPr>
         <p:spPr>
           <a:xfrm>
-            <a:off x="3890772" y="1325880"/>
-            <a:ext cx="1847088" cy="384048"/>
-          </a:xfrm>
-          <a:prstGeom prst="rect">
-            <a:avLst/>
-          </a:prstGeom>
-          <a:noFill/>
-          <a:ln/>
-        </p:spPr>
-        <p:txBody>
-          <a:bodyPr wrap="square" lIns="0" tIns="0" rIns="0" bIns="0" rtlCol="0" anchor="ctr"/>
-          <a:lstStyle/>
-          <a:p>
-            <a:pPr indent="0" marL="0">
-              <a:buNone/>
-            </a:pPr>
-            <a:r>
-              <a:rPr lang="en-US" sz="1600" b="1" dirty="0">
-                <a:solidFill>
-                  <a:schemeClr val="tx1"/>
-                </a:solidFill>
-              </a:rPr>
-              <a:t>Test</a:t>
-            </a:r>
-            <a:endParaRPr lang="en-US" sz="1600" dirty="0"/>
-          </a:p>
-        </p:txBody>
-      </p:sp>
-      <p:sp>
-        <p:nvSpPr>
-          <p:cNvPr id="12" name="card-body-248"/>
-          <p:cNvSpPr txBox="1"/>
-          <p:nvPr/>
-        </p:nvSpPr>
-        <p:spPr>
-          <a:xfrm>
-            <a:off x="3451860" y="1783080"/>
-            <a:ext cx="2286000" cy="1325880"/>
+            <a:off x="640080" y="3063240"/>
+            <a:ext cx="4343400" cy="1417320"/>
           </a:xfrm>
           <a:prstGeom prst="rect">
             <a:avLst/>
@@ -11944,14 +12135,14 @@
               <a:buChar char="•"/>
             </a:pPr>
             <a:r>
-              <a:rPr lang="en-US" sz="1400" dirty="0">
-                <a:solidFill>
-                  <a:schemeClr val="tx1"/>
-                </a:solidFill>
-              </a:rPr>
-              <a:t>Six test scenes</a:t>
-            </a:r>
-            <a:endParaRPr lang="en-US" sz="1400" dirty="0"/>
+              <a:rPr lang="en-US" sz="1300" dirty="0">
+                <a:solidFill>
+                  <a:schemeClr val="tx1"/>
+                </a:solidFill>
+              </a:rPr>
+              <a:t>As root, once per boot: ufw rules, start stunnel</a:t>
+            </a:r>
+            <a:endParaRPr lang="en-US" sz="1300" dirty="0"/>
           </a:p>
           <a:p>
             <a:pPr marL="342900" indent="-342900">
@@ -11962,14 +12153,14 @@
               <a:buChar char="•"/>
             </a:pPr>
             <a:r>
-              <a:rPr lang="en-US" sz="1400" dirty="0">
-                <a:solidFill>
-                  <a:schemeClr val="tx1"/>
-                </a:solidFill>
-              </a:rPr>
-              <a:t>xwd screenshots</a:t>
-            </a:r>
-            <a:endParaRPr lang="en-US" sz="1400" dirty="0"/>
+              <a:rPr lang="en-US" sz="1300" dirty="0">
+                <a:solidFill>
+                  <a:schemeClr val="tx1"/>
+                </a:solidFill>
+              </a:rPr>
+              <a:t>Run the viewer with NV_CXR_SERVER_PORT=48324 --cloudxr --cloudxr-profile apple-vision-pro</a:t>
+            </a:r>
+            <a:endParaRPr lang="en-US" sz="1300" dirty="0"/>
           </a:p>
           <a:p>
             <a:pPr marL="342900" indent="-342900">
@@ -11980,49 +12171,31 @@
               <a:buChar char="•"/>
             </a:pPr>
             <a:r>
-              <a:rPr lang="en-US" sz="1400" dirty="0">
-                <a:solidFill>
-                  <a:schemeClr val="tx1"/>
-                </a:solidFill>
-              </a:rPr>
-              <a:t>usdchecker</a:t>
-            </a:r>
-            <a:endParaRPr lang="en-US" sz="1400" dirty="0"/>
-          </a:p>
-          <a:p>
-            <a:pPr marL="342900" indent="-342900">
-              <a:spcAft>
-                <a:spcPts val="400"/>
-              </a:spcAft>
-              <a:buSzPct val="100000"/>
-              <a:buChar char="•"/>
-            </a:pPr>
-            <a:r>
-              <a:rPr lang="en-US" sz="1400" dirty="0">
-                <a:solidFill>
-                  <a:schemeClr val="tx1"/>
-                </a:solidFill>
-              </a:rPr>
-              <a:t>CloudXR, no headset</a:t>
-            </a:r>
-            <a:endParaRPr lang="en-US" sz="1400" dirty="0"/>
-          </a:p>
-        </p:txBody>
-      </p:sp>
-      <p:sp>
-        <p:nvSpPr>
-          <p:cNvPr id="13" name="card-249"/>
+              <a:rPr lang="en-US" sz="1300" dirty="0">
+                <a:solidFill>
+                  <a:schemeClr val="tx1"/>
+                </a:solidFill>
+              </a:rPr>
+              <a:t>In the headset: Manual IP Address 157.253.113.156, Connect</a:t>
+            </a:r>
+            <a:endParaRPr lang="en-US" sz="1300" dirty="0"/>
+          </a:p>
+        </p:txBody>
+      </p:sp>
+      <p:sp>
+        <p:nvSpPr>
+          <p:cNvPr id="17" name="card-253"/>
           <p:cNvSpPr/>
           <p:nvPr/>
         </p:nvSpPr>
         <p:spPr>
           <a:xfrm>
-            <a:off x="6080760" y="1188720"/>
-            <a:ext cx="2606040" cy="2011680"/>
+            <a:off x="5394960" y="2468880"/>
+            <a:ext cx="3291840" cy="2103120"/>
           </a:xfrm>
           <a:prstGeom prst="roundRect">
             <a:avLst>
-              <a:gd name="adj" fmla="val 3636"/>
+              <a:gd name="adj" fmla="val 3478"/>
             </a:avLst>
           </a:prstGeom>
           <a:solidFill>
@@ -12038,39 +12211,14 @@
       </p:sp>
       <p:sp>
         <p:nvSpPr>
-          <p:cNvPr id="14" name="badge-250"/>
-          <p:cNvSpPr/>
-          <p:nvPr/>
-        </p:nvSpPr>
-        <p:spPr>
-          <a:xfrm>
-            <a:off x="6217920" y="1325880"/>
-            <a:ext cx="384048" cy="384048"/>
-          </a:xfrm>
-          <a:prstGeom prst="ellipse">
-            <a:avLst/>
-          </a:prstGeom>
-          <a:solidFill>
-            <a:schemeClr val="accent1"/>
-          </a:solidFill>
-          <a:ln w="12700">
-            <a:solidFill>
-              <a:schemeClr val="accent1"/>
-            </a:solidFill>
-            <a:prstDash val="solid"/>
-          </a:ln>
-        </p:spPr>
-      </p:sp>
-      <p:sp>
-        <p:nvSpPr>
-          <p:cNvPr id="15" name="badge-text-251"/>
+          <p:cNvPr id="18" name="card-head-254"/>
           <p:cNvSpPr txBox="1"/>
           <p:nvPr/>
         </p:nvSpPr>
         <p:spPr>
           <a:xfrm>
-            <a:off x="6217920" y="1325880"/>
-            <a:ext cx="384048" cy="384048"/>
+            <a:off x="5577840" y="2606040"/>
+            <a:ext cx="2971800" cy="384048"/>
           </a:xfrm>
           <a:prstGeom prst="rect">
             <a:avLst/>
@@ -12082,67 +12230,31 @@
           <a:bodyPr wrap="square" lIns="0" tIns="0" rIns="0" bIns="0" rtlCol="0" anchor="ctr"/>
           <a:lstStyle/>
           <a:p>
-            <a:pPr algn="ctr" indent="0" marL="0">
-              <a:buNone/>
-            </a:pPr>
-            <a:r>
-              <a:rPr lang="en-US" sz="1400" b="1" dirty="0">
-                <a:solidFill>
-                  <a:schemeClr val="tx1"/>
-                </a:solidFill>
-              </a:rPr>
-              <a:t>D</a:t>
-            </a:r>
-            <a:endParaRPr lang="en-US" sz="1400" dirty="0"/>
-          </a:p>
-        </p:txBody>
-      </p:sp>
-      <p:sp>
-        <p:nvSpPr>
-          <p:cNvPr id="16" name="card-head-252"/>
+            <a:pPr indent="0" marL="0">
+              <a:buNone/>
+            </a:pPr>
+            <a:r>
+              <a:rPr lang="en-US" sz="1600" b="1" dirty="0">
+                <a:solidFill>
+                  <a:schemeClr val="tx1"/>
+                </a:solidFill>
+              </a:rPr>
+              <a:t>XR menu</a:t>
+            </a:r>
+            <a:endParaRPr lang="en-US" sz="1600" dirty="0"/>
+          </a:p>
+        </p:txBody>
+      </p:sp>
+      <p:sp>
+        <p:nvSpPr>
+          <p:cNvPr id="19" name="card-body-255"/>
           <p:cNvSpPr txBox="1"/>
           <p:nvPr/>
         </p:nvSpPr>
         <p:spPr>
           <a:xfrm>
-            <a:off x="6702552" y="1325880"/>
-            <a:ext cx="1847088" cy="384048"/>
-          </a:xfrm>
-          <a:prstGeom prst="rect">
-            <a:avLst/>
-          </a:prstGeom>
-          <a:noFill/>
-          <a:ln/>
-        </p:spPr>
-        <p:txBody>
-          <a:bodyPr wrap="square" lIns="0" tIns="0" rIns="0" bIns="0" rtlCol="0" anchor="ctr"/>
-          <a:lstStyle/>
-          <a:p>
-            <a:pPr indent="0" marL="0">
-              <a:buNone/>
-            </a:pPr>
-            <a:r>
-              <a:rPr lang="en-US" sz="1600" b="1" dirty="0">
-                <a:solidFill>
-                  <a:schemeClr val="tx1"/>
-                </a:solidFill>
-              </a:rPr>
-              <a:t>Document</a:t>
-            </a:r>
-            <a:endParaRPr lang="en-US" sz="1600" dirty="0"/>
-          </a:p>
-        </p:txBody>
-      </p:sp>
-      <p:sp>
-        <p:nvSpPr>
-          <p:cNvPr id="17" name="card-body-253"/>
-          <p:cNvSpPr txBox="1"/>
-          <p:nvPr/>
-        </p:nvSpPr>
-        <p:spPr>
-          <a:xfrm>
-            <a:off x="6263640" y="1783080"/>
-            <a:ext cx="2286000" cy="1325880"/>
+            <a:off x="5577840" y="3063240"/>
+            <a:ext cx="2971800" cy="1417320"/>
           </a:xfrm>
           <a:prstGeom prst="rect">
             <a:avLst/>
@@ -12162,14 +12274,14 @@
               <a:buChar char="•"/>
             </a:pPr>
             <a:r>
-              <a:rPr lang="en-US" sz="1400" dirty="0">
-                <a:solidFill>
-                  <a:schemeClr val="tx1"/>
-                </a:solidFill>
-              </a:rPr>
-              <a:t>LiterateP/ book</a:t>
-            </a:r>
-            <a:endParaRPr lang="en-US" sz="1400" dirty="0"/>
+              <a:rPr lang="en-US" sz="1300" dirty="0">
+                <a:solidFill>
+                  <a:schemeClr val="tx1"/>
+                </a:solidFill>
+              </a:rPr>
+              <a:t>Shows every interface's IPv4 address</a:t>
+            </a:r>
+            <a:endParaRPr lang="en-US" sz="1300" dirty="0"/>
           </a:p>
           <a:p>
             <a:pPr marL="342900" indent="-342900">
@@ -12180,14 +12292,14 @@
               <a:buChar char="•"/>
             </a:pPr>
             <a:r>
-              <a:rPr lang="en-US" sz="1400" dirty="0">
-                <a:solidFill>
-                  <a:schemeClr val="tx1"/>
-                </a:solidFill>
-              </a:rPr>
-              <a:t>lp.py check</a:t>
-            </a:r>
-            <a:endParaRPr lang="en-US" sz="1400" dirty="0"/>
+              <a:rPr lang="en-US" sz="1300" dirty="0">
+                <a:solidFill>
+                  <a:schemeClr val="tx1"/>
+                </a:solidFill>
+              </a:rPr>
+              <a:t>Port read from the service (server-port)</a:t>
+            </a:r>
+            <a:endParaRPr lang="en-US" sz="1300" dirty="0"/>
           </a:p>
           <a:p>
             <a:pPr marL="342900" indent="-342900">
@@ -12198,132 +12310,14 @@
               <a:buChar char="•"/>
             </a:pPr>
             <a:r>
-              <a:rPr lang="en-US" sz="1400" dirty="0">
-                <a:solidFill>
-                  <a:schemeClr val="tx1"/>
-                </a:solidFill>
-              </a:rPr>
-              <a:t>logbook.md</a:t>
-            </a:r>
-            <a:endParaRPr lang="en-US" sz="1400" dirty="0"/>
-          </a:p>
-          <a:p>
-            <a:pPr marL="342900" indent="-342900">
-              <a:spcAft>
-                <a:spcPts val="400"/>
-              </a:spcAft>
-              <a:buSzPct val="100000"/>
-              <a:buChar char="•"/>
-            </a:pPr>
-            <a:r>
-              <a:rPr lang="en-US" sz="1400" dirty="0">
-                <a:solidFill>
-                  <a:schemeClr val="tx1"/>
-                </a:solidFill>
-              </a:rPr>
-              <a:t>CLOUDXR.md</a:t>
-            </a:r>
-            <a:endParaRPr lang="en-US" sz="1400" dirty="0"/>
-          </a:p>
-        </p:txBody>
-      </p:sp>
-      <p:sp>
-        <p:nvSpPr>
-          <p:cNvPr id="18" name="code-bg-254"/>
-          <p:cNvSpPr/>
-          <p:nvPr/>
-        </p:nvSpPr>
-        <p:spPr>
-          <a:xfrm>
-            <a:off x="457200" y="3429000"/>
-            <a:ext cx="8229600" cy="1097280"/>
-          </a:xfrm>
-          <a:prstGeom prst="roundRect">
-            <a:avLst>
-              <a:gd name="adj" fmla="val 5000"/>
-            </a:avLst>
-          </a:prstGeom>
-          <a:solidFill>
-            <a:schemeClr val="tx1"/>
-          </a:solidFill>
-          <a:ln w="12700">
-            <a:solidFill>
-              <a:schemeClr val="tx1"/>
-            </a:solidFill>
-            <a:prstDash val="solid"/>
-          </a:ln>
-        </p:spPr>
-      </p:sp>
-      <p:sp>
-        <p:nvSpPr>
-          <p:cNvPr id="19" name="code-255"/>
-          <p:cNvSpPr txBox="1"/>
-          <p:nvPr/>
-        </p:nvSpPr>
-        <p:spPr>
-          <a:xfrm>
-            <a:off x="640080" y="3538728"/>
-            <a:ext cx="7863840" cy="877824"/>
-          </a:xfrm>
-          <a:prstGeom prst="rect">
-            <a:avLst/>
-          </a:prstGeom>
-          <a:noFill/>
-          <a:ln/>
-        </p:spPr>
-        <p:txBody>
-          <a:bodyPr wrap="square" lIns="0" tIns="0" rIns="0" bIns="0" rtlCol="0" anchor="t"/>
-          <a:lstStyle/>
-          <a:p>
-            <a:pPr indent="0" marL="0">
-              <a:buNone/>
-            </a:pPr>
-            <a:r>
-              <a:rPr lang="en-US" sz="1200" dirty="0">
-                <a:solidFill>
-                  <a:schemeClr val="bg1"/>
-                </a:solidFill>
-                <a:latin typeface="Courier New" pitchFamily="34" charset="0"/>
-                <a:ea typeface="Courier New" pitchFamily="34" charset="-122"/>
-                <a:cs typeface="Courier New" pitchFamily="34" charset="-120"/>
-              </a:rPr>
-              <a:t>cmake -S UsdOptixViewer -B build &amp;&amp; cmake --build build -j</a:t>
-            </a:r>
-            <a:endParaRPr lang="en-US" sz="1200" dirty="0"/>
-          </a:p>
-          <a:p>
-            <a:pPr indent="0" marL="0">
-              <a:buNone/>
-            </a:pPr>
-            <a:r>
-              <a:rPr lang="en-US" sz="1200" dirty="0">
-                <a:solidFill>
-                  <a:schemeClr val="bg1"/>
-                </a:solidFill>
-                <a:latin typeface="Courier New" pitchFamily="34" charset="0"/>
-                <a:ea typeface="Courier New" pitchFamily="34" charset="-122"/>
-                <a:cs typeface="Courier New" pitchFamily="34" charset="-120"/>
-              </a:rPr>
-              <a:t>./build/UsdOptixViewer assets/textured_scene.usda --select /World/Box</a:t>
-            </a:r>
-            <a:endParaRPr lang="en-US" sz="1200" dirty="0"/>
-          </a:p>
-          <a:p>
-            <a:pPr indent="0" marL="0">
-              <a:buNone/>
-            </a:pPr>
-            <a:r>
-              <a:rPr lang="en-US" sz="1200" dirty="0">
-                <a:solidFill>
-                  <a:schemeClr val="bg1"/>
-                </a:solidFill>
-                <a:latin typeface="Courier New" pitchFamily="34" charset="0"/>
-                <a:ea typeface="Courier New" pitchFamily="34" charset="-122"/>
-                <a:cs typeface="Courier New" pitchFamily="34" charset="-120"/>
-              </a:rPr>
-              <a:t>python3 LiterateP/lp.py check      # must print ok for every file</a:t>
-            </a:r>
-            <a:endParaRPr lang="en-US" sz="1200" dirty="0"/>
+              <a:rPr lang="en-US" sz="1300" dirty="0">
+                <a:solidFill>
+                  <a:schemeClr val="tx1"/>
+                </a:solidFill>
+              </a:rPr>
+              <a:t>Without stunnel: error 0x800B1004</a:t>
+            </a:r>
+            <a:endParaRPr lang="en-US" sz="1300" dirty="0"/>
           </a:p>
         </p:txBody>
       </p:sp>
@@ -12407,6 +12401,868 @@
         </p:nvSpPr>
         <p:spPr>
           <a:xfrm>
+            <a:off x="457200" y="274320"/>
+            <a:ext cx="8229600" cy="685800"/>
+          </a:xfrm>
+          <a:prstGeom prst="rect">
+            <a:avLst/>
+          </a:prstGeom>
+          <a:noFill/>
+          <a:ln/>
+        </p:spPr>
+        <p:txBody>
+          <a:bodyPr wrap="square" lIns="0" tIns="0" rIns="0" bIns="0" rtlCol="0" anchor="ctr"/>
+          <a:lstStyle/>
+          <a:p>
+            <a:pPr algn="l" indent="0" marL="0">
+              <a:buNone/>
+            </a:pPr>
+            <a:r>
+              <a:rPr lang="en-US" sz="3000" b="1" dirty="0">
+                <a:solidFill>
+                  <a:schemeClr val="tx1"/>
+                </a:solidFill>
+              </a:rPr>
+              <a:t>Build, test and document</a:t>
+            </a:r>
+            <a:endParaRPr lang="en-US" sz="3000" dirty="0"/>
+          </a:p>
+        </p:txBody>
+      </p:sp>
+      <p:sp>
+        <p:nvSpPr>
+          <p:cNvPr id="3" name="card-256"/>
+          <p:cNvSpPr/>
+          <p:nvPr/>
+        </p:nvSpPr>
+        <p:spPr>
+          <a:xfrm>
+            <a:off x="457200" y="1188720"/>
+            <a:ext cx="2606040" cy="2011680"/>
+          </a:xfrm>
+          <a:prstGeom prst="roundRect">
+            <a:avLst>
+              <a:gd name="adj" fmla="val 3636"/>
+            </a:avLst>
+          </a:prstGeom>
+          <a:solidFill>
+            <a:schemeClr val="bg2"/>
+          </a:solidFill>
+          <a:ln w="12700">
+            <a:solidFill>
+              <a:schemeClr val="bg2"/>
+            </a:solidFill>
+            <a:prstDash val="solid"/>
+          </a:ln>
+        </p:spPr>
+      </p:sp>
+      <p:sp>
+        <p:nvSpPr>
+          <p:cNvPr id="4" name="badge-257"/>
+          <p:cNvSpPr/>
+          <p:nvPr/>
+        </p:nvSpPr>
+        <p:spPr>
+          <a:xfrm>
+            <a:off x="594360" y="1325880"/>
+            <a:ext cx="384048" cy="384048"/>
+          </a:xfrm>
+          <a:prstGeom prst="ellipse">
+            <a:avLst/>
+          </a:prstGeom>
+          <a:solidFill>
+            <a:schemeClr val="accent1"/>
+          </a:solidFill>
+          <a:ln w="12700">
+            <a:solidFill>
+              <a:schemeClr val="accent1"/>
+            </a:solidFill>
+            <a:prstDash val="solid"/>
+          </a:ln>
+        </p:spPr>
+      </p:sp>
+      <p:sp>
+        <p:nvSpPr>
+          <p:cNvPr id="5" name="badge-text-258"/>
+          <p:cNvSpPr txBox="1"/>
+          <p:nvPr/>
+        </p:nvSpPr>
+        <p:spPr>
+          <a:xfrm>
+            <a:off x="594360" y="1325880"/>
+            <a:ext cx="384048" cy="384048"/>
+          </a:xfrm>
+          <a:prstGeom prst="rect">
+            <a:avLst/>
+          </a:prstGeom>
+          <a:noFill/>
+          <a:ln/>
+        </p:spPr>
+        <p:txBody>
+          <a:bodyPr wrap="square" lIns="0" tIns="0" rIns="0" bIns="0" rtlCol="0" anchor="ctr"/>
+          <a:lstStyle/>
+          <a:p>
+            <a:pPr algn="ctr" indent="0" marL="0">
+              <a:buNone/>
+            </a:pPr>
+            <a:r>
+              <a:rPr lang="en-US" sz="1400" b="1" dirty="0">
+                <a:solidFill>
+                  <a:schemeClr val="tx1"/>
+                </a:solidFill>
+              </a:rPr>
+              <a:t>B</a:t>
+            </a:r>
+            <a:endParaRPr lang="en-US" sz="1400" dirty="0"/>
+          </a:p>
+        </p:txBody>
+      </p:sp>
+      <p:sp>
+        <p:nvSpPr>
+          <p:cNvPr id="6" name="card-head-259"/>
+          <p:cNvSpPr txBox="1"/>
+          <p:nvPr/>
+        </p:nvSpPr>
+        <p:spPr>
+          <a:xfrm>
+            <a:off x="1078992" y="1325880"/>
+            <a:ext cx="1847088" cy="384048"/>
+          </a:xfrm>
+          <a:prstGeom prst="rect">
+            <a:avLst/>
+          </a:prstGeom>
+          <a:noFill/>
+          <a:ln/>
+        </p:spPr>
+        <p:txBody>
+          <a:bodyPr wrap="square" lIns="0" tIns="0" rIns="0" bIns="0" rtlCol="0" anchor="ctr"/>
+          <a:lstStyle/>
+          <a:p>
+            <a:pPr indent="0" marL="0">
+              <a:buNone/>
+            </a:pPr>
+            <a:r>
+              <a:rPr lang="en-US" sz="1600" b="1" dirty="0">
+                <a:solidFill>
+                  <a:schemeClr val="tx1"/>
+                </a:solidFill>
+              </a:rPr>
+              <a:t>Build</a:t>
+            </a:r>
+            <a:endParaRPr lang="en-US" sz="1600" dirty="0"/>
+          </a:p>
+        </p:txBody>
+      </p:sp>
+      <p:sp>
+        <p:nvSpPr>
+          <p:cNvPr id="7" name="card-body-260"/>
+          <p:cNvSpPr txBox="1"/>
+          <p:nvPr/>
+        </p:nvSpPr>
+        <p:spPr>
+          <a:xfrm>
+            <a:off x="640080" y="1783080"/>
+            <a:ext cx="2286000" cy="1325880"/>
+          </a:xfrm>
+          <a:prstGeom prst="rect">
+            <a:avLst/>
+          </a:prstGeom>
+          <a:noFill/>
+          <a:ln/>
+        </p:spPr>
+        <p:txBody>
+          <a:bodyPr wrap="square" lIns="0" tIns="0" rIns="0" bIns="0" rtlCol="0" anchor="t"/>
+          <a:lstStyle/>
+          <a:p>
+            <a:pPr marL="342900" indent="-342900">
+              <a:spcAft>
+                <a:spcPts val="400"/>
+              </a:spcAft>
+              <a:buSzPct val="100000"/>
+              <a:buChar char="•"/>
+            </a:pPr>
+            <a:r>
+              <a:rPr lang="en-US" sz="1400" dirty="0">
+                <a:solidFill>
+                  <a:schemeClr val="tx1"/>
+                </a:solidFill>
+              </a:rPr>
+              <a:t>CMake 3.28, C++20</a:t>
+            </a:r>
+            <a:endParaRPr lang="en-US" sz="1400" dirty="0"/>
+          </a:p>
+          <a:p>
+            <a:pPr marL="342900" indent="-342900">
+              <a:spcAft>
+                <a:spcPts val="400"/>
+              </a:spcAft>
+              <a:buSzPct val="100000"/>
+              <a:buChar char="•"/>
+            </a:pPr>
+            <a:r>
+              <a:rPr lang="en-US" sz="1400" dirty="0">
+                <a:solidFill>
+                  <a:schemeClr val="tx1"/>
+                </a:solidFill>
+              </a:rPr>
+              <a:t>OptiX-IR embedded</a:t>
+            </a:r>
+            <a:endParaRPr lang="en-US" sz="1400" dirty="0"/>
+          </a:p>
+          <a:p>
+            <a:pPr marL="342900" indent="-342900">
+              <a:spcAft>
+                <a:spcPts val="400"/>
+              </a:spcAft>
+              <a:buSzPct val="100000"/>
+              <a:buChar char="•"/>
+            </a:pPr>
+            <a:r>
+              <a:rPr lang="en-US" sz="1400" dirty="0">
+                <a:solidFill>
+                  <a:schemeClr val="tx1"/>
+                </a:solidFill>
+              </a:rPr>
+              <a:t>Tools in /opt/viztools</a:t>
+            </a:r>
+            <a:endParaRPr lang="en-US" sz="1400" dirty="0"/>
+          </a:p>
+          <a:p>
+            <a:pPr marL="342900" indent="-342900">
+              <a:spcAft>
+                <a:spcPts val="400"/>
+              </a:spcAft>
+              <a:buSzPct val="100000"/>
+              <a:buChar char="•"/>
+            </a:pPr>
+            <a:r>
+              <a:rPr lang="en-US" sz="1400" dirty="0">
+                <a:solidFill>
+                  <a:schemeClr val="tx1"/>
+                </a:solidFill>
+              </a:rPr>
+              <a:t>No warnings</a:t>
+            </a:r>
+            <a:endParaRPr lang="en-US" sz="1400" dirty="0"/>
+          </a:p>
+        </p:txBody>
+      </p:sp>
+      <p:sp>
+        <p:nvSpPr>
+          <p:cNvPr id="8" name="card-261"/>
+          <p:cNvSpPr/>
+          <p:nvPr/>
+        </p:nvSpPr>
+        <p:spPr>
+          <a:xfrm>
+            <a:off x="3268980" y="1188720"/>
+            <a:ext cx="2606040" cy="2011680"/>
+          </a:xfrm>
+          <a:prstGeom prst="roundRect">
+            <a:avLst>
+              <a:gd name="adj" fmla="val 3636"/>
+            </a:avLst>
+          </a:prstGeom>
+          <a:solidFill>
+            <a:schemeClr val="bg2"/>
+          </a:solidFill>
+          <a:ln w="12700">
+            <a:solidFill>
+              <a:schemeClr val="bg2"/>
+            </a:solidFill>
+            <a:prstDash val="solid"/>
+          </a:ln>
+        </p:spPr>
+      </p:sp>
+      <p:sp>
+        <p:nvSpPr>
+          <p:cNvPr id="9" name="badge-262"/>
+          <p:cNvSpPr/>
+          <p:nvPr/>
+        </p:nvSpPr>
+        <p:spPr>
+          <a:xfrm>
+            <a:off x="3406140" y="1325880"/>
+            <a:ext cx="384048" cy="384048"/>
+          </a:xfrm>
+          <a:prstGeom prst="ellipse">
+            <a:avLst/>
+          </a:prstGeom>
+          <a:solidFill>
+            <a:schemeClr val="accent1"/>
+          </a:solidFill>
+          <a:ln w="12700">
+            <a:solidFill>
+              <a:schemeClr val="accent1"/>
+            </a:solidFill>
+            <a:prstDash val="solid"/>
+          </a:ln>
+        </p:spPr>
+      </p:sp>
+      <p:sp>
+        <p:nvSpPr>
+          <p:cNvPr id="10" name="badge-text-263"/>
+          <p:cNvSpPr txBox="1"/>
+          <p:nvPr/>
+        </p:nvSpPr>
+        <p:spPr>
+          <a:xfrm>
+            <a:off x="3406140" y="1325880"/>
+            <a:ext cx="384048" cy="384048"/>
+          </a:xfrm>
+          <a:prstGeom prst="rect">
+            <a:avLst/>
+          </a:prstGeom>
+          <a:noFill/>
+          <a:ln/>
+        </p:spPr>
+        <p:txBody>
+          <a:bodyPr wrap="square" lIns="0" tIns="0" rIns="0" bIns="0" rtlCol="0" anchor="ctr"/>
+          <a:lstStyle/>
+          <a:p>
+            <a:pPr algn="ctr" indent="0" marL="0">
+              <a:buNone/>
+            </a:pPr>
+            <a:r>
+              <a:rPr lang="en-US" sz="1400" b="1" dirty="0">
+                <a:solidFill>
+                  <a:schemeClr val="tx1"/>
+                </a:solidFill>
+              </a:rPr>
+              <a:t>T</a:t>
+            </a:r>
+            <a:endParaRPr lang="en-US" sz="1400" dirty="0"/>
+          </a:p>
+        </p:txBody>
+      </p:sp>
+      <p:sp>
+        <p:nvSpPr>
+          <p:cNvPr id="11" name="card-head-264"/>
+          <p:cNvSpPr txBox="1"/>
+          <p:nvPr/>
+        </p:nvSpPr>
+        <p:spPr>
+          <a:xfrm>
+            <a:off x="3890772" y="1325880"/>
+            <a:ext cx="1847088" cy="384048"/>
+          </a:xfrm>
+          <a:prstGeom prst="rect">
+            <a:avLst/>
+          </a:prstGeom>
+          <a:noFill/>
+          <a:ln/>
+        </p:spPr>
+        <p:txBody>
+          <a:bodyPr wrap="square" lIns="0" tIns="0" rIns="0" bIns="0" rtlCol="0" anchor="ctr"/>
+          <a:lstStyle/>
+          <a:p>
+            <a:pPr indent="0" marL="0">
+              <a:buNone/>
+            </a:pPr>
+            <a:r>
+              <a:rPr lang="en-US" sz="1600" b="1" dirty="0">
+                <a:solidFill>
+                  <a:schemeClr val="tx1"/>
+                </a:solidFill>
+              </a:rPr>
+              <a:t>Test</a:t>
+            </a:r>
+            <a:endParaRPr lang="en-US" sz="1600" dirty="0"/>
+          </a:p>
+        </p:txBody>
+      </p:sp>
+      <p:sp>
+        <p:nvSpPr>
+          <p:cNvPr id="12" name="card-body-265"/>
+          <p:cNvSpPr txBox="1"/>
+          <p:nvPr/>
+        </p:nvSpPr>
+        <p:spPr>
+          <a:xfrm>
+            <a:off x="3451860" y="1783080"/>
+            <a:ext cx="2286000" cy="1325880"/>
+          </a:xfrm>
+          <a:prstGeom prst="rect">
+            <a:avLst/>
+          </a:prstGeom>
+          <a:noFill/>
+          <a:ln/>
+        </p:spPr>
+        <p:txBody>
+          <a:bodyPr wrap="square" lIns="0" tIns="0" rIns="0" bIns="0" rtlCol="0" anchor="t"/>
+          <a:lstStyle/>
+          <a:p>
+            <a:pPr marL="342900" indent="-342900">
+              <a:spcAft>
+                <a:spcPts val="400"/>
+              </a:spcAft>
+              <a:buSzPct val="100000"/>
+              <a:buChar char="•"/>
+            </a:pPr>
+            <a:r>
+              <a:rPr lang="en-US" sz="1400" dirty="0">
+                <a:solidFill>
+                  <a:schemeClr val="tx1"/>
+                </a:solidFill>
+              </a:rPr>
+              <a:t>Six test scenes</a:t>
+            </a:r>
+            <a:endParaRPr lang="en-US" sz="1400" dirty="0"/>
+          </a:p>
+          <a:p>
+            <a:pPr marL="342900" indent="-342900">
+              <a:spcAft>
+                <a:spcPts val="400"/>
+              </a:spcAft>
+              <a:buSzPct val="100000"/>
+              <a:buChar char="•"/>
+            </a:pPr>
+            <a:r>
+              <a:rPr lang="en-US" sz="1400" dirty="0">
+                <a:solidFill>
+                  <a:schemeClr val="tx1"/>
+                </a:solidFill>
+              </a:rPr>
+              <a:t>xwd screenshots</a:t>
+            </a:r>
+            <a:endParaRPr lang="en-US" sz="1400" dirty="0"/>
+          </a:p>
+          <a:p>
+            <a:pPr marL="342900" indent="-342900">
+              <a:spcAft>
+                <a:spcPts val="400"/>
+              </a:spcAft>
+              <a:buSzPct val="100000"/>
+              <a:buChar char="•"/>
+            </a:pPr>
+            <a:r>
+              <a:rPr lang="en-US" sz="1400" dirty="0">
+                <a:solidFill>
+                  <a:schemeClr val="tx1"/>
+                </a:solidFill>
+              </a:rPr>
+              <a:t>usdchecker</a:t>
+            </a:r>
+            <a:endParaRPr lang="en-US" sz="1400" dirty="0"/>
+          </a:p>
+          <a:p>
+            <a:pPr marL="342900" indent="-342900">
+              <a:spcAft>
+                <a:spcPts val="400"/>
+              </a:spcAft>
+              <a:buSzPct val="100000"/>
+              <a:buChar char="•"/>
+            </a:pPr>
+            <a:r>
+              <a:rPr lang="en-US" sz="1400" dirty="0">
+                <a:solidFill>
+                  <a:schemeClr val="tx1"/>
+                </a:solidFill>
+              </a:rPr>
+              <a:t>CloudXR, no headset</a:t>
+            </a:r>
+            <a:endParaRPr lang="en-US" sz="1400" dirty="0"/>
+          </a:p>
+        </p:txBody>
+      </p:sp>
+      <p:sp>
+        <p:nvSpPr>
+          <p:cNvPr id="13" name="card-266"/>
+          <p:cNvSpPr/>
+          <p:nvPr/>
+        </p:nvSpPr>
+        <p:spPr>
+          <a:xfrm>
+            <a:off x="6080760" y="1188720"/>
+            <a:ext cx="2606040" cy="2011680"/>
+          </a:xfrm>
+          <a:prstGeom prst="roundRect">
+            <a:avLst>
+              <a:gd name="adj" fmla="val 3636"/>
+            </a:avLst>
+          </a:prstGeom>
+          <a:solidFill>
+            <a:schemeClr val="bg2"/>
+          </a:solidFill>
+          <a:ln w="12700">
+            <a:solidFill>
+              <a:schemeClr val="bg2"/>
+            </a:solidFill>
+            <a:prstDash val="solid"/>
+          </a:ln>
+        </p:spPr>
+      </p:sp>
+      <p:sp>
+        <p:nvSpPr>
+          <p:cNvPr id="14" name="badge-267"/>
+          <p:cNvSpPr/>
+          <p:nvPr/>
+        </p:nvSpPr>
+        <p:spPr>
+          <a:xfrm>
+            <a:off x="6217920" y="1325880"/>
+            <a:ext cx="384048" cy="384048"/>
+          </a:xfrm>
+          <a:prstGeom prst="ellipse">
+            <a:avLst/>
+          </a:prstGeom>
+          <a:solidFill>
+            <a:schemeClr val="accent1"/>
+          </a:solidFill>
+          <a:ln w="12700">
+            <a:solidFill>
+              <a:schemeClr val="accent1"/>
+            </a:solidFill>
+            <a:prstDash val="solid"/>
+          </a:ln>
+        </p:spPr>
+      </p:sp>
+      <p:sp>
+        <p:nvSpPr>
+          <p:cNvPr id="15" name="badge-text-268"/>
+          <p:cNvSpPr txBox="1"/>
+          <p:nvPr/>
+        </p:nvSpPr>
+        <p:spPr>
+          <a:xfrm>
+            <a:off x="6217920" y="1325880"/>
+            <a:ext cx="384048" cy="384048"/>
+          </a:xfrm>
+          <a:prstGeom prst="rect">
+            <a:avLst/>
+          </a:prstGeom>
+          <a:noFill/>
+          <a:ln/>
+        </p:spPr>
+        <p:txBody>
+          <a:bodyPr wrap="square" lIns="0" tIns="0" rIns="0" bIns="0" rtlCol="0" anchor="ctr"/>
+          <a:lstStyle/>
+          <a:p>
+            <a:pPr algn="ctr" indent="0" marL="0">
+              <a:buNone/>
+            </a:pPr>
+            <a:r>
+              <a:rPr lang="en-US" sz="1400" b="1" dirty="0">
+                <a:solidFill>
+                  <a:schemeClr val="tx1"/>
+                </a:solidFill>
+              </a:rPr>
+              <a:t>D</a:t>
+            </a:r>
+            <a:endParaRPr lang="en-US" sz="1400" dirty="0"/>
+          </a:p>
+        </p:txBody>
+      </p:sp>
+      <p:sp>
+        <p:nvSpPr>
+          <p:cNvPr id="16" name="card-head-269"/>
+          <p:cNvSpPr txBox="1"/>
+          <p:nvPr/>
+        </p:nvSpPr>
+        <p:spPr>
+          <a:xfrm>
+            <a:off x="6702552" y="1325880"/>
+            <a:ext cx="1847088" cy="384048"/>
+          </a:xfrm>
+          <a:prstGeom prst="rect">
+            <a:avLst/>
+          </a:prstGeom>
+          <a:noFill/>
+          <a:ln/>
+        </p:spPr>
+        <p:txBody>
+          <a:bodyPr wrap="square" lIns="0" tIns="0" rIns="0" bIns="0" rtlCol="0" anchor="ctr"/>
+          <a:lstStyle/>
+          <a:p>
+            <a:pPr indent="0" marL="0">
+              <a:buNone/>
+            </a:pPr>
+            <a:r>
+              <a:rPr lang="en-US" sz="1600" b="1" dirty="0">
+                <a:solidFill>
+                  <a:schemeClr val="tx1"/>
+                </a:solidFill>
+              </a:rPr>
+              <a:t>Document</a:t>
+            </a:r>
+            <a:endParaRPr lang="en-US" sz="1600" dirty="0"/>
+          </a:p>
+        </p:txBody>
+      </p:sp>
+      <p:sp>
+        <p:nvSpPr>
+          <p:cNvPr id="17" name="card-body-270"/>
+          <p:cNvSpPr txBox="1"/>
+          <p:nvPr/>
+        </p:nvSpPr>
+        <p:spPr>
+          <a:xfrm>
+            <a:off x="6263640" y="1783080"/>
+            <a:ext cx="2286000" cy="1325880"/>
+          </a:xfrm>
+          <a:prstGeom prst="rect">
+            <a:avLst/>
+          </a:prstGeom>
+          <a:noFill/>
+          <a:ln/>
+        </p:spPr>
+        <p:txBody>
+          <a:bodyPr wrap="square" lIns="0" tIns="0" rIns="0" bIns="0" rtlCol="0" anchor="t"/>
+          <a:lstStyle/>
+          <a:p>
+            <a:pPr marL="342900" indent="-342900">
+              <a:spcAft>
+                <a:spcPts val="400"/>
+              </a:spcAft>
+              <a:buSzPct val="100000"/>
+              <a:buChar char="•"/>
+            </a:pPr>
+            <a:r>
+              <a:rPr lang="en-US" sz="1400" dirty="0">
+                <a:solidFill>
+                  <a:schemeClr val="tx1"/>
+                </a:solidFill>
+              </a:rPr>
+              <a:t>LiterateP/ book</a:t>
+            </a:r>
+            <a:endParaRPr lang="en-US" sz="1400" dirty="0"/>
+          </a:p>
+          <a:p>
+            <a:pPr marL="342900" indent="-342900">
+              <a:spcAft>
+                <a:spcPts val="400"/>
+              </a:spcAft>
+              <a:buSzPct val="100000"/>
+              <a:buChar char="•"/>
+            </a:pPr>
+            <a:r>
+              <a:rPr lang="en-US" sz="1400" dirty="0">
+                <a:solidFill>
+                  <a:schemeClr val="tx1"/>
+                </a:solidFill>
+              </a:rPr>
+              <a:t>lp.py check</a:t>
+            </a:r>
+            <a:endParaRPr lang="en-US" sz="1400" dirty="0"/>
+          </a:p>
+          <a:p>
+            <a:pPr marL="342900" indent="-342900">
+              <a:spcAft>
+                <a:spcPts val="400"/>
+              </a:spcAft>
+              <a:buSzPct val="100000"/>
+              <a:buChar char="•"/>
+            </a:pPr>
+            <a:r>
+              <a:rPr lang="en-US" sz="1400" dirty="0">
+                <a:solidFill>
+                  <a:schemeClr val="tx1"/>
+                </a:solidFill>
+              </a:rPr>
+              <a:t>logbook.md</a:t>
+            </a:r>
+            <a:endParaRPr lang="en-US" sz="1400" dirty="0"/>
+          </a:p>
+          <a:p>
+            <a:pPr marL="342900" indent="-342900">
+              <a:spcAft>
+                <a:spcPts val="400"/>
+              </a:spcAft>
+              <a:buSzPct val="100000"/>
+              <a:buChar char="•"/>
+            </a:pPr>
+            <a:r>
+              <a:rPr lang="en-US" sz="1400" dirty="0">
+                <a:solidFill>
+                  <a:schemeClr val="tx1"/>
+                </a:solidFill>
+              </a:rPr>
+              <a:t>CLOUDXR.md</a:t>
+            </a:r>
+            <a:endParaRPr lang="en-US" sz="1400" dirty="0"/>
+          </a:p>
+        </p:txBody>
+      </p:sp>
+      <p:sp>
+        <p:nvSpPr>
+          <p:cNvPr id="18" name="code-bg-271"/>
+          <p:cNvSpPr/>
+          <p:nvPr/>
+        </p:nvSpPr>
+        <p:spPr>
+          <a:xfrm>
+            <a:off x="457200" y="3429000"/>
+            <a:ext cx="8229600" cy="1097280"/>
+          </a:xfrm>
+          <a:prstGeom prst="roundRect">
+            <a:avLst>
+              <a:gd name="adj" fmla="val 5000"/>
+            </a:avLst>
+          </a:prstGeom>
+          <a:solidFill>
+            <a:schemeClr val="tx1"/>
+          </a:solidFill>
+          <a:ln w="12700">
+            <a:solidFill>
+              <a:schemeClr val="tx1"/>
+            </a:solidFill>
+            <a:prstDash val="solid"/>
+          </a:ln>
+        </p:spPr>
+      </p:sp>
+      <p:sp>
+        <p:nvSpPr>
+          <p:cNvPr id="19" name="code-272"/>
+          <p:cNvSpPr txBox="1"/>
+          <p:nvPr/>
+        </p:nvSpPr>
+        <p:spPr>
+          <a:xfrm>
+            <a:off x="640080" y="3538728"/>
+            <a:ext cx="7863840" cy="877824"/>
+          </a:xfrm>
+          <a:prstGeom prst="rect">
+            <a:avLst/>
+          </a:prstGeom>
+          <a:noFill/>
+          <a:ln/>
+        </p:spPr>
+        <p:txBody>
+          <a:bodyPr wrap="square" lIns="0" tIns="0" rIns="0" bIns="0" rtlCol="0" anchor="t"/>
+          <a:lstStyle/>
+          <a:p>
+            <a:pPr indent="0" marL="0">
+              <a:buNone/>
+            </a:pPr>
+            <a:r>
+              <a:rPr lang="en-US" sz="1200" dirty="0">
+                <a:solidFill>
+                  <a:schemeClr val="bg1"/>
+                </a:solidFill>
+                <a:latin typeface="Courier New" pitchFamily="34" charset="0"/>
+                <a:ea typeface="Courier New" pitchFamily="34" charset="-122"/>
+                <a:cs typeface="Courier New" pitchFamily="34" charset="-120"/>
+              </a:rPr>
+              <a:t>cmake -S UsdOptixViewer -B build &amp;&amp; cmake --build build -j</a:t>
+            </a:r>
+            <a:endParaRPr lang="en-US" sz="1200" dirty="0"/>
+          </a:p>
+          <a:p>
+            <a:pPr indent="0" marL="0">
+              <a:buNone/>
+            </a:pPr>
+            <a:r>
+              <a:rPr lang="en-US" sz="1200" dirty="0">
+                <a:solidFill>
+                  <a:schemeClr val="bg1"/>
+                </a:solidFill>
+                <a:latin typeface="Courier New" pitchFamily="34" charset="0"/>
+                <a:ea typeface="Courier New" pitchFamily="34" charset="-122"/>
+                <a:cs typeface="Courier New" pitchFamily="34" charset="-120"/>
+              </a:rPr>
+              <a:t>./build/UsdOptixViewer assets/textured_scene.usda --select /World/Box</a:t>
+            </a:r>
+            <a:endParaRPr lang="en-US" sz="1200" dirty="0"/>
+          </a:p>
+          <a:p>
+            <a:pPr indent="0" marL="0">
+              <a:buNone/>
+            </a:pPr>
+            <a:r>
+              <a:rPr lang="en-US" sz="1200" dirty="0">
+                <a:solidFill>
+                  <a:schemeClr val="bg1"/>
+                </a:solidFill>
+                <a:latin typeface="Courier New" pitchFamily="34" charset="0"/>
+                <a:ea typeface="Courier New" pitchFamily="34" charset="-122"/>
+                <a:cs typeface="Courier New" pitchFamily="34" charset="-120"/>
+              </a:rPr>
+              <a:t>python3 LiterateP/lp.py check      # must print ok for every file</a:t>
+            </a:r>
+            <a:endParaRPr lang="en-US" sz="1200" dirty="0"/>
+          </a:p>
+        </p:txBody>
+      </p:sp>
+      <p:sp>
+        <p:nvSpPr>
+          <p:cNvPr id="25" name="Slide Number Placeholder 0"/>
+          <p:cNvSpPr>
+            <a:spLocks noGrp="1"/>
+          </p:cNvSpPr>
+          <p:nvPr>
+            <p:ph type="sldNum" sz="quarter" idx="4294967295"/>
+          </p:nvPr>
+        </p:nvSpPr>
+        <p:spPr>
+          <a:xfrm>
+            <a:off x="8229600" y="4754880"/>
+            <a:ext cx="457200" cy="274320"/>
+          </a:xfrm>
+          <a:prstGeom prst="rect">
+            <a:avLst/>
+          </a:prstGeom>
+          <a:extLst>
+            <a:ext uri="{C572A759-6A51-4108-AA02-DFA0A04FC94B}">
+              <ma14:wrappingTextBoxFlag xmlns:ma14="http://schemas.microsoft.com/office/mac/drawingml/2011/main" val="0"/>
+            </a:ext>
+          </a:extLst>
+        </p:spPr>
+        <p:txBody>
+          <a:bodyPr/>
+          <a:lstStyle>
+            <a:lvl1pPr>
+              <a:defRPr sz="1000">
+                <a:solidFill>
+                  <a:schemeClr val="accent4"/>
+                </a:solidFill>
+              </a:defRPr>
+            </a:lvl1pPr>
+          </a:lstStyle>
+          <a:p>
+            <a:pPr algn="r"/>
+            <a:fld id="{F7021451-1387-4CA6-816F-3879F97B5CBC}" type="slidenum">
+              <a:rPr b="0" lang="en-US"/>
+              <a:t>24</a:t>
+            </a:fld>
+            <a:endParaRPr lang="en-US"/>
+          </a:p>
+        </p:txBody>
+      </p:sp>
+    </p:spTree>
+  </p:cSld>
+  <p:clrMapOvr>
+    <a:masterClrMapping/>
+  </p:clrMapOvr>
+</p:sld>
+</file>
+
+<file path=ppt/slides/slide25.xml><?xml version="1.0" encoding="utf-8"?>
+<p:sld xmlns:a="http://schemas.openxmlformats.org/drawingml/2006/main" xmlns:r="http://schemas.openxmlformats.org/officeDocument/2006/relationships" xmlns:p="http://schemas.openxmlformats.org/presentationml/2006/main">
+  <p:cSld name="Slide 25">
+    <p:spTree>
+      <p:nvGrpSpPr>
+        <p:cNvPr id="1" name=""/>
+        <p:cNvGrpSpPr/>
+        <p:nvPr/>
+      </p:nvGrpSpPr>
+      <p:grpSpPr>
+        <a:xfrm>
+          <a:off x="0" y="0"/>
+          <a:ext cx="0" cy="0"/>
+          <a:chOff x="0" y="0"/>
+          <a:chExt cx="0" cy="0"/>
+        </a:xfrm>
+      </p:grpSpPr>
+      <p:sp>
+        <p:nvSpPr>
+          <p:cNvPr id="2" name="Text 0"/>
+          <p:cNvSpPr/>
+          <p:nvPr>
+            <p:ph idx="100" type="title" hasCustomPrompt="1"/>
+          </p:nvPr>
+        </p:nvSpPr>
+        <p:spPr>
+          <a:xfrm>
             <a:off x="548640" y="1417320"/>
             <a:ext cx="8046720" cy="1005840"/>
           </a:xfrm>
@@ -13362,7 +14218,7 @@
                   <a:schemeClr val="bg1"/>
                 </a:solidFill>
               </a:rPr>
-              <a:t>EnTT registry + FlatGeometry</a:t>
+              <a:t>RenderMesh per prim, materials, cameras</a:t>
             </a:r>
             <a:endParaRPr lang="en-US" sz="1400" dirty="0"/>
           </a:p>
@@ -13439,7 +14295,7 @@
                   <a:schemeClr val="bg1"/>
                 </a:solidFill>
               </a:rPr>
-              <a:t>GAS, SBT, launch</a:t>
+              <a:t>GAS per mesh, IAS, SBT</a:t>
             </a:r>
             <a:endParaRPr lang="en-US" sz="1400" dirty="0"/>
           </a:p>
@@ -14104,7 +14960,7 @@
                   <a:schemeClr val="bg2"/>
                 </a:solidFill>
               </a:rPr>
-              <a:t>Scene.h / Scene.cpp: USD stage → EnTT registry → world-space triangles</a:t>
+              <a:t>Scene.h / Scene.cpp: USD stage → one RenderMesh per prim → GPU</a:t>
             </a:r>
             <a:endParaRPr lang="en-US" sz="1600" dirty="0"/>
           </a:p>
@@ -14212,7 +15068,7 @@
                   <a:schemeClr val="tx1"/>
                 </a:solidFill>
               </a:rPr>
-              <a:t>One entity per prim</a:t>
+              <a:t>The stage is the scene graph</a:t>
             </a:r>
             <a:endParaRPr lang="en-US" sz="3000" dirty="0"/>
           </a:p>
@@ -14220,7 +15076,7 @@
       </p:sp>
       <p:sp>
         <p:nvSpPr>
-          <p:cNvPr id="3" name="comp-46"/>
+          <p:cNvPr id="3" name="use-46"/>
           <p:cNvSpPr/>
           <p:nvPr/>
         </p:nvSpPr>
@@ -14308,7 +15164,7 @@
       </p:sp>
       <p:sp>
         <p:nvSpPr>
-          <p:cNvPr id="6" name="comp-text-49"/>
+          <p:cNvPr id="6" name="use-text-49"/>
           <p:cNvSpPr txBox="1"/>
           <p:nvPr/>
         </p:nvSpPr>
@@ -14335,11 +15191,8 @@
                 <a:solidFill>
                   <a:schemeClr val="tx1"/>
                 </a:solidFill>
-                <a:latin typeface="Courier New" pitchFamily="34" charset="0"/>
-                <a:ea typeface="Courier New" pitchFamily="34" charset="-122"/>
-                <a:cs typeface="Courier New" pitchFamily="34" charset="-120"/>
-              </a:rPr>
-              <a:t>PrimInfo</a:t>
+              </a:rPr>
+              <a:t>Hierarchy panel</a:t>
             </a:r>
             <a:endParaRPr lang="en-US" sz="1400" dirty="0"/>
           </a:p>
@@ -14353,7 +15206,7 @@
                   <a:schemeClr val="tx2"/>
                 </a:solidFill>
               </a:rPr>
-              <a:t>path, name, type name</a:t>
+              <a:t>walks UsdPrim children, filters by name</a:t>
             </a:r>
             <a:endParaRPr lang="en-US" sz="1400" dirty="0"/>
           </a:p>
@@ -14361,7 +15214,7 @@
       </p:sp>
       <p:sp>
         <p:nvSpPr>
-          <p:cNvPr id="7" name="comp-50"/>
+          <p:cNvPr id="7" name="use-50"/>
           <p:cNvSpPr/>
           <p:nvPr/>
         </p:nvSpPr>
@@ -14449,7 +15302,7 @@
       </p:sp>
       <p:sp>
         <p:nvSpPr>
-          <p:cNvPr id="10" name="comp-text-53"/>
+          <p:cNvPr id="10" name="use-text-53"/>
           <p:cNvSpPr txBox="1"/>
           <p:nvPr/>
         </p:nvSpPr>
@@ -14476,11 +15329,8 @@
                 <a:solidFill>
                   <a:schemeClr val="tx1"/>
                 </a:solidFill>
-                <a:latin typeface="Courier New" pitchFamily="34" charset="0"/>
-                <a:ea typeface="Courier New" pitchFamily="34" charset="-122"/>
-                <a:cs typeface="Courier New" pitchFamily="34" charset="-120"/>
-              </a:rPr>
-              <a:t>Hierarchy</a:t>
+              </a:rPr>
+              <a:t>Inspector</a:t>
             </a:r>
             <a:endParaRPr lang="en-US" sz="1400" dirty="0"/>
           </a:p>
@@ -14494,7 +15344,7 @@
                   <a:schemeClr val="tx2"/>
                 </a:solidFill>
               </a:rPr>
-              <a:t>parent and children entities</a:t>
+              <a:t>reads the prim's type and properties</a:t>
             </a:r>
             <a:endParaRPr lang="en-US" sz="1400" dirty="0"/>
           </a:p>
@@ -14502,7 +15352,7 @@
       </p:sp>
       <p:sp>
         <p:nvSpPr>
-          <p:cNvPr id="11" name="comp-54"/>
+          <p:cNvPr id="11" name="use-54"/>
           <p:cNvSpPr/>
           <p:nvPr/>
         </p:nvSpPr>
@@ -14590,7 +15440,7 @@
       </p:sp>
       <p:sp>
         <p:nvSpPr>
-          <p:cNvPr id="14" name="comp-text-57"/>
+          <p:cNvPr id="14" name="use-text-57"/>
           <p:cNvSpPr txBox="1"/>
           <p:nvPr/>
         </p:nvSpPr>
@@ -14621,7 +15471,7 @@
                 <a:ea typeface="Courier New" pitchFamily="34" charset="-122"/>
                 <a:cs typeface="Courier New" pitchFamily="34" charset="-120"/>
               </a:rPr>
-              <a:t>MeshGeometry</a:t>
+              <a:t>meshIndex(SdfPath)</a:t>
             </a:r>
             <a:endParaRPr lang="en-US" sz="1400" dirty="0"/>
           </a:p>
@@ -14635,7 +15485,7 @@
                   <a:schemeClr val="tx2"/>
                 </a:solidFill>
               </a:rPr>
-              <a:t>triangle range, material, mesh id</a:t>
+              <a:t>prim → RenderMesh id, for --select</a:t>
             </a:r>
             <a:endParaRPr lang="en-US" sz="1400" dirty="0"/>
           </a:p>
@@ -14643,7 +15493,7 @@
       </p:sp>
       <p:sp>
         <p:nvSpPr>
-          <p:cNvPr id="15" name="comp-58"/>
+          <p:cNvPr id="15" name="use-58"/>
           <p:cNvSpPr/>
           <p:nvPr/>
         </p:nvSpPr>
@@ -14731,7 +15581,7 @@
       </p:sp>
       <p:sp>
         <p:nvSpPr>
-          <p:cNvPr id="18" name="comp-text-61"/>
+          <p:cNvPr id="18" name="use-text-61"/>
           <p:cNvSpPr txBox="1"/>
           <p:nvPr/>
         </p:nvSpPr>
@@ -14762,7 +15612,7 @@
                 <a:ea typeface="Courier New" pitchFamily="34" charset="-122"/>
                 <a:cs typeface="Courier New" pitchFamily="34" charset="-120"/>
               </a:rPr>
-              <a:t>CameraView</a:t>
+              <a:t>cameraIndex(SdfPath)</a:t>
             </a:r>
             <a:endParaRPr lang="en-US" sz="1400" dirty="0"/>
           </a:p>
@@ -14776,7 +15626,7 @@
                   <a:schemeClr val="tx2"/>
                 </a:solidFill>
               </a:rPr>
-              <a:t>index into Scene::cameras()</a:t>
+              <a:t>prim → SceneCamera, for --camera</a:t>
             </a:r>
             <a:endParaRPr lang="en-US" sz="1400" dirty="0"/>
           </a:p>
@@ -14839,7 +15689,7 @@
                   <a:schemeClr val="tx1"/>
                 </a:solidFill>
               </a:rPr>
-              <a:t>Why a registry</a:t>
+              <a:t>No second scene graph</a:t>
             </a:r>
             <a:endParaRPr lang="en-US" sz="1600" dirty="0"/>
           </a:p>
@@ -14879,7 +15729,7 @@
                   <a:schemeClr val="tx1"/>
                 </a:solidFill>
               </a:rPr>
-              <a:t>The tree panel walks Hierarchy; the inspector reads the prim back by PrimInfo::path</a:t>
+              <a:t>Names, types and the tree come straight from USD</a:t>
             </a:r>
             <a:endParaRPr lang="en-US" sz="1400" dirty="0"/>
           </a:p>
@@ -14897,7 +15747,7 @@
                   <a:schemeClr val="tx1"/>
                 </a:solidFill>
               </a:rPr>
-              <a:t>Only drawn prims get MeshGeometry, so "is it rendered?" is one lookup</a:t>
+              <a:t>The selection is an SdfPath</a:t>
             </a:r>
             <a:endParaRPr lang="en-US" sz="1400" dirty="0"/>
           </a:p>
@@ -14915,7 +15765,7 @@
                   <a:schemeClr val="tx1"/>
                 </a:solidFill>
               </a:rPr>
-              <a:t>Picking maps a mesh id back to its entity</a:t>
+              <a:t>Picking: mesh id → RenderMesh::path → prim</a:t>
             </a:r>
             <a:endParaRPr lang="en-US" sz="1400" dirty="0"/>
           </a:p>
@@ -14933,7 +15783,7 @@
                   <a:schemeClr val="tx1"/>
                 </a:solidFill>
               </a:rPr>
-              <a:t>Instance proxies are included, so instanced models appear in full</a:t>
+              <a:t>Instance proxies are traversed, so instanced models appear in full</a:t>
             </a:r>
             <a:endParaRPr lang="en-US" sz="1400" dirty="0"/>
           </a:p>
@@ -15041,7 +15891,7 @@
                   <a:schemeClr val="tx1"/>
                 </a:solidFill>
               </a:rPr>
-              <a:t>Flattening the geometry</a:t>
+              <a:t>From prim to RenderMesh</a:t>
             </a:r>
             <a:endParaRPr lang="en-US" sz="3000" dirty="0"/>
           </a:p>
@@ -15609,7 +16459,7 @@
                   <a:schemeClr val="tx1"/>
                 </a:solidFill>
               </a:rPr>
-              <a:t>Transform</a:t>
+              <a:t>Weld</a:t>
             </a:r>
             <a:endParaRPr lang="en-US" sz="1600" dirty="0"/>
           </a:p>
@@ -15645,7 +16495,7 @@
                   <a:schemeClr val="tx1"/>
                 </a:solidFill>
               </a:rPr>
-              <a:t>UsdGeomXformCache to world space, bounds grown</a:t>
+              <a:t>meshoptimizer merges equal corners, sorts by material and space</a:t>
             </a:r>
             <a:endParaRPr lang="en-US" sz="1300" dirty="0"/>
           </a:p>
@@ -15660,7 +16510,7 @@
         <p:spPr>
           <a:xfrm>
             <a:off x="457200" y="2834640"/>
-            <a:ext cx="8229600" cy="1691640"/>
+            <a:ext cx="5669280" cy="1691640"/>
           </a:xfrm>
           <a:prstGeom prst="roundRect">
             <a:avLst>
@@ -15687,7 +16537,7 @@
         <p:spPr>
           <a:xfrm>
             <a:off x="640080" y="2944368"/>
-            <a:ext cx="7863840" cy="1472184"/>
+            <a:ext cx="5303520" cy="1472184"/>
           </a:xfrm>
           <a:prstGeom prst="rect">
             <a:avLst/>
@@ -15711,7 +16561,7 @@
                 <a:ea typeface="Courier New" pitchFamily="34" charset="-122"/>
                 <a:cs typeface="Courier New" pitchFamily="34" charset="-120"/>
               </a:rPr>
-              <a:t>struct FlatGeometry {                  // one soup, ready for one GAS</a:t>
+              <a:t>struct RenderMesh {           // one per renderable prim</a:t>
             </a:r>
             <a:endParaRPr lang="en-US" sz="1200" dirty="0"/>
           </a:p>
@@ -15728,7 +16578,7 @@
                 <a:ea typeface="Courier New" pitchFamily="34" charset="-122"/>
                 <a:cs typeface="Courier New" pitchFamily="34" charset="-120"/>
               </a:rPr>
-              <a:t>    vertices, indices;                 // shared positions</a:t>
+              <a:t>    SdfPath path;</a:t>
             </a:r>
             <a:endParaRPr lang="en-US" sz="1200" dirty="0"/>
           </a:p>
@@ -15745,7 +16595,7 @@
                 <a:ea typeface="Courier New" pitchFamily="34" charset="-122"/>
                 <a:cs typeface="Courier New" pitchFamily="34" charset="-120"/>
               </a:rPr>
-              <a:t>    triMesh, triMaterial;              // per triangle</a:t>
+              <a:t>    array&lt;float,12&gt; toWorld;  // local → world</a:t>
             </a:r>
             <a:endParaRPr lang="en-US" sz="1200" dirty="0"/>
           </a:p>
@@ -15762,7 +16612,7 @@
                 <a:ea typeface="Courier New" pitchFamily="34" charset="-122"/>
                 <a:cs typeface="Courier New" pitchFamily="34" charset="-120"/>
               </a:rPr>
-              <a:t>    triUVs (6), triNormals (9);        // per triangle corner</a:t>
+              <a:t>    positions, normals, uvs;  // per vertex</a:t>
             </a:r>
             <a:endParaRPr lang="en-US" sz="1200" dirty="0"/>
           </a:p>
@@ -15779,7 +16629,7 @@
                 <a:ea typeface="Courier New" pitchFamily="34" charset="-122"/>
                 <a:cs typeface="Courier New" pitchFamily="34" charset="-120"/>
               </a:rPr>
-              <a:t>    materials, textures, meshEntity, bounds;</a:t>
+              <a:t>    indices, triMaterial;     // per triangle</a:t>
             </a:r>
             <a:endParaRPr lang="en-US" sz="1200" dirty="0"/>
           </a:p>
@@ -15799,6 +16649,81 @@
               <a:t>};</a:t>
             </a:r>
             <a:endParaRPr lang="en-US" sz="1200" dirty="0"/>
+          </a:p>
+        </p:txBody>
+      </p:sp>
+      <p:sp>
+        <p:nvSpPr>
+          <p:cNvPr id="24" name="weld-stat"/>
+          <p:cNvSpPr txBox="1"/>
+          <p:nvPr/>
+        </p:nvSpPr>
+        <p:spPr>
+          <a:xfrm>
+            <a:off x="6400800" y="2880360"/>
+            <a:ext cx="2286000" cy="685800"/>
+          </a:xfrm>
+          <a:prstGeom prst="rect">
+            <a:avLst/>
+          </a:prstGeom>
+          <a:noFill/>
+          <a:ln/>
+        </p:spPr>
+        <p:txBody>
+          <a:bodyPr wrap="square" lIns="0" tIns="0" rIns="0" bIns="0" rtlCol="0" anchor="ctr"/>
+          <a:lstStyle/>
+          <a:p>
+            <a:pPr indent="0" marL="0">
+              <a:buNone/>
+            </a:pPr>
+            <a:r>
+              <a:rPr lang="en-US" sz="4000" b="1" dirty="0">
+                <a:solidFill>
+                  <a:schemeClr val="accent1"/>
+                </a:solidFill>
+                <a:latin typeface="Cambria" pitchFamily="34" charset="0"/>
+                <a:ea typeface="Cambria" pitchFamily="34" charset="-122"/>
+                <a:cs typeface="Cambria" pitchFamily="34" charset="-120"/>
+              </a:rPr>
+              <a:t>36 → 20</a:t>
+            </a:r>
+            <a:endParaRPr lang="en-US" sz="4000" dirty="0"/>
+          </a:p>
+        </p:txBody>
+      </p:sp>
+      <p:sp>
+        <p:nvSpPr>
+          <p:cNvPr id="25" name="weld-label"/>
+          <p:cNvSpPr txBox="1"/>
+          <p:nvPr/>
+        </p:nvSpPr>
+        <p:spPr>
+          <a:xfrm>
+            <a:off x="6400800" y="3611880"/>
+            <a:ext cx="2286000" cy="822960"/>
+          </a:xfrm>
+          <a:prstGeom prst="rect">
+            <a:avLst/>
+          </a:prstGeom>
+          <a:noFill/>
+          <a:ln/>
+        </p:spPr>
+        <p:txBody>
+          <a:bodyPr wrap="square" lIns="0" tIns="0" rIns="0" bIns="0" rtlCol="0" anchor="t"/>
+          <a:lstStyle/>
+          <a:p>
+            <a:pPr indent="0" marL="0">
+              <a:buNone/>
+            </a:pPr>
+            <a:r>
+              <a:rPr lang="en-US" sz="1300" dirty="0">
+                <a:solidFill>
+                  <a:schemeClr val="tx1"/>
+                </a:solidFill>
+              </a:rPr>
+              <a:t>corners → vertices in the textured box after welding</a:t>
+            </a:r>
+            <a:endParaRPr lang="en-US" sz="1300" dirty="0"/>
           </a:p>
         </p:txBody>
       </p:sp>

</xml_diff>